<commit_message>
Finish up results with cleaning for draft 1
</commit_message>
<xml_diff>
--- a/images/Initial Results Check-In.pptx
+++ b/images/Initial Results Check-In.pptx
@@ -7,18 +7,23 @@
   <p:sldIdLst>
     <p:sldId id="256" r:id="rId2"/>
     <p:sldId id="260" r:id="rId3"/>
-    <p:sldId id="261" r:id="rId4"/>
-    <p:sldId id="257" r:id="rId5"/>
-    <p:sldId id="262" r:id="rId6"/>
-    <p:sldId id="265" r:id="rId7"/>
-    <p:sldId id="269" r:id="rId8"/>
-    <p:sldId id="258" r:id="rId9"/>
-    <p:sldId id="268" r:id="rId10"/>
+    <p:sldId id="257" r:id="rId4"/>
+    <p:sldId id="262" r:id="rId5"/>
+    <p:sldId id="265" r:id="rId6"/>
+    <p:sldId id="269" r:id="rId7"/>
+    <p:sldId id="258" r:id="rId8"/>
+    <p:sldId id="268" r:id="rId9"/>
+    <p:sldId id="267" r:id="rId10"/>
     <p:sldId id="263" r:id="rId11"/>
-    <p:sldId id="267" r:id="rId12"/>
-    <p:sldId id="266" r:id="rId13"/>
-    <p:sldId id="259" r:id="rId14"/>
-    <p:sldId id="264" r:id="rId15"/>
+    <p:sldId id="264" r:id="rId12"/>
+    <p:sldId id="261" r:id="rId13"/>
+    <p:sldId id="273" r:id="rId14"/>
+    <p:sldId id="272" r:id="rId15"/>
+    <p:sldId id="274" r:id="rId16"/>
+    <p:sldId id="275" r:id="rId17"/>
+    <p:sldId id="266" r:id="rId18"/>
+    <p:sldId id="259" r:id="rId19"/>
+    <p:sldId id="271" r:id="rId20"/>
   </p:sldIdLst>
   <p:sldSz cx="12192000" cy="6858000"/>
   <p:notesSz cx="6858000" cy="9144000"/>
@@ -128,7 +133,7 @@
 <file path=ppt/revisionInfo.xml><?xml version="1.0" encoding="utf-8"?>
 <p1510:revInfo xmlns:a="http://schemas.openxmlformats.org/drawingml/2006/main" xmlns:r="http://schemas.openxmlformats.org/officeDocument/2006/relationships" xmlns:p1510="http://schemas.microsoft.com/office/powerpoint/2015/10/main">
   <p1510:revLst>
-    <p1510:client id="{8B39C58B-65A5-4A8D-9A3B-6122693E2276}" v="6" dt="2026-08-12T18:39:58.237"/>
+    <p1510:client id="{8B39C58B-65A5-4A8D-9A3B-6122693E2276}" v="15" dt="2026-08-20T05:39:05.875"/>
   </p1510:revLst>
 </p1510:revInfo>
 </file>
@@ -137,8 +142,8 @@
 <pc:chgInfo xmlns:a="http://schemas.openxmlformats.org/drawingml/2006/main" xmlns:r="http://schemas.openxmlformats.org/officeDocument/2006/relationships" xmlns:ac="http://schemas.microsoft.com/office/drawing/2013/main/command" xmlns:pc="http://schemas.microsoft.com/office/powerpoint/2013/main/command">
   <pc:docChgLst>
     <pc:chgData name="Savannah Karin Miller" userId="22c948fc-cece-4b89-9db3-f9f8a6b29aef" providerId="ADAL" clId="{39DE2C0E-7095-495B-81F3-37AFAFAFC50B}"/>
-    <pc:docChg chg="custSel addSld modSld sldOrd">
-      <pc:chgData name="Savannah Karin Miller" userId="22c948fc-cece-4b89-9db3-f9f8a6b29aef" providerId="ADAL" clId="{39DE2C0E-7095-495B-81F3-37AFAFAFC50B}" dt="2026-08-12T18:43:02.906" v="961" actId="14100"/>
+    <pc:docChg chg="undo custSel addSld delSld modSld sldOrd">
+      <pc:chgData name="Savannah Karin Miller" userId="22c948fc-cece-4b89-9db3-f9f8a6b29aef" providerId="ADAL" clId="{39DE2C0E-7095-495B-81F3-37AFAFAFC50B}" dt="2026-08-20T05:45:03.552" v="1573" actId="1076"/>
       <pc:docMkLst>
         <pc:docMk/>
       </pc:docMkLst>
@@ -203,59 +208,73 @@
           </ac:picMkLst>
         </pc:picChg>
       </pc:sldChg>
-      <pc:sldChg chg="modSp mod">
-        <pc:chgData name="Savannah Karin Miller" userId="22c948fc-cece-4b89-9db3-f9f8a6b29aef" providerId="ADAL" clId="{39DE2C0E-7095-495B-81F3-37AFAFAFC50B}" dt="2026-08-12T18:13:11.463" v="231" actId="1076"/>
+      <pc:sldChg chg="modSp del mod">
+        <pc:chgData name="Savannah Karin Miller" userId="22c948fc-cece-4b89-9db3-f9f8a6b29aef" providerId="ADAL" clId="{39DE2C0E-7095-495B-81F3-37AFAFAFC50B}" dt="2026-08-20T04:03:19.984" v="962" actId="2696"/>
         <pc:sldMkLst>
           <pc:docMk/>
           <pc:sldMk cId="200294253" sldId="259"/>
         </pc:sldMkLst>
+      </pc:sldChg>
+      <pc:sldChg chg="addSp modSp add mod">
+        <pc:chgData name="Savannah Karin Miller" userId="22c948fc-cece-4b89-9db3-f9f8a6b29aef" providerId="ADAL" clId="{39DE2C0E-7095-495B-81F3-37AFAFAFC50B}" dt="2026-08-20T04:09:18.366" v="1197" actId="20577"/>
+        <pc:sldMkLst>
+          <pc:docMk/>
+          <pc:sldMk cId="3100768396" sldId="259"/>
+        </pc:sldMkLst>
+        <pc:spChg chg="mod">
+          <ac:chgData name="Savannah Karin Miller" userId="22c948fc-cece-4b89-9db3-f9f8a6b29aef" providerId="ADAL" clId="{39DE2C0E-7095-495B-81F3-37AFAFAFC50B}" dt="2026-08-20T04:08:40.794" v="1172" actId="20577"/>
+          <ac:spMkLst>
+            <pc:docMk/>
+            <pc:sldMk cId="3100768396" sldId="259"/>
+            <ac:spMk id="2" creationId="{09088601-E465-1B77-5DFB-E21827DA476A}"/>
+          </ac:spMkLst>
+        </pc:spChg>
+        <pc:spChg chg="add mod">
+          <ac:chgData name="Savannah Karin Miller" userId="22c948fc-cece-4b89-9db3-f9f8a6b29aef" providerId="ADAL" clId="{39DE2C0E-7095-495B-81F3-37AFAFAFC50B}" dt="2026-08-20T04:09:18.366" v="1197" actId="20577"/>
+          <ac:spMkLst>
+            <pc:docMk/>
+            <pc:sldMk cId="3100768396" sldId="259"/>
+            <ac:spMk id="3" creationId="{E3C8B9F9-8670-9659-A378-8E86907B9F4D}"/>
+          </ac:spMkLst>
+        </pc:spChg>
         <pc:picChg chg="mod">
-          <ac:chgData name="Savannah Karin Miller" userId="22c948fc-cece-4b89-9db3-f9f8a6b29aef" providerId="ADAL" clId="{39DE2C0E-7095-495B-81F3-37AFAFAFC50B}" dt="2026-08-12T18:13:11.463" v="231" actId="1076"/>
+          <ac:chgData name="Savannah Karin Miller" userId="22c948fc-cece-4b89-9db3-f9f8a6b29aef" providerId="ADAL" clId="{39DE2C0E-7095-495B-81F3-37AFAFAFC50B}" dt="2026-08-20T04:09:00.321" v="1183" actId="14100"/>
           <ac:picMkLst>
             <pc:docMk/>
-            <pc:sldMk cId="200294253" sldId="259"/>
+            <pc:sldMk cId="3100768396" sldId="259"/>
             <ac:picMk id="7" creationId="{20941BF4-9E9F-5C22-FA4A-AD297C6EAEB7}"/>
           </ac:picMkLst>
         </pc:picChg>
         <pc:picChg chg="mod">
-          <ac:chgData name="Savannah Karin Miller" userId="22c948fc-cece-4b89-9db3-f9f8a6b29aef" providerId="ADAL" clId="{39DE2C0E-7095-495B-81F3-37AFAFAFC50B}" dt="2026-08-12T18:13:05.112" v="229" actId="1076"/>
+          <ac:chgData name="Savannah Karin Miller" userId="22c948fc-cece-4b89-9db3-f9f8a6b29aef" providerId="ADAL" clId="{39DE2C0E-7095-495B-81F3-37AFAFAFC50B}" dt="2026-08-20T04:09:06.482" v="1185" actId="14100"/>
           <ac:picMkLst>
             <pc:docMk/>
-            <pc:sldMk cId="200294253" sldId="259"/>
+            <pc:sldMk cId="3100768396" sldId="259"/>
             <ac:picMk id="11" creationId="{DEFE12E2-1EED-6518-94C9-AB0F5F088D46}"/>
           </ac:picMkLst>
         </pc:picChg>
       </pc:sldChg>
-      <pc:sldChg chg="addSp delSp modSp mod ord">
-        <pc:chgData name="Savannah Karin Miller" userId="22c948fc-cece-4b89-9db3-f9f8a6b29aef" providerId="ADAL" clId="{39DE2C0E-7095-495B-81F3-37AFAFAFC50B}" dt="2026-08-12T18:42:06.810" v="927"/>
+      <pc:sldChg chg="addSp delSp modSp del mod ord">
+        <pc:chgData name="Savannah Karin Miller" userId="22c948fc-cece-4b89-9db3-f9f8a6b29aef" providerId="ADAL" clId="{39DE2C0E-7095-495B-81F3-37AFAFAFC50B}" dt="2026-08-20T04:03:19.984" v="962" actId="2696"/>
         <pc:sldMkLst>
           <pc:docMk/>
           <pc:sldMk cId="149973421" sldId="261"/>
         </pc:sldMkLst>
+      </pc:sldChg>
+      <pc:sldChg chg="modSp add mod">
+        <pc:chgData name="Savannah Karin Miller" userId="22c948fc-cece-4b89-9db3-f9f8a6b29aef" providerId="ADAL" clId="{39DE2C0E-7095-495B-81F3-37AFAFAFC50B}" dt="2026-08-20T04:03:59.357" v="1031" actId="20577"/>
+        <pc:sldMkLst>
+          <pc:docMk/>
+          <pc:sldMk cId="2465619183" sldId="261"/>
+        </pc:sldMkLst>
         <pc:spChg chg="mod">
-          <ac:chgData name="Savannah Karin Miller" userId="22c948fc-cece-4b89-9db3-f9f8a6b29aef" providerId="ADAL" clId="{39DE2C0E-7095-495B-81F3-37AFAFAFC50B}" dt="2026-08-12T14:41:15.870" v="205" actId="20577"/>
+          <ac:chgData name="Savannah Karin Miller" userId="22c948fc-cece-4b89-9db3-f9f8a6b29aef" providerId="ADAL" clId="{39DE2C0E-7095-495B-81F3-37AFAFAFC50B}" dt="2026-08-20T04:03:59.357" v="1031" actId="20577"/>
           <ac:spMkLst>
             <pc:docMk/>
-            <pc:sldMk cId="149973421" sldId="261"/>
-            <ac:spMk id="3" creationId="{2802FEA1-9264-90A9-4FE1-B432BB70A3C3}"/>
+            <pc:sldMk cId="2465619183" sldId="261"/>
+            <ac:spMk id="2" creationId="{5FB283D9-45D4-2FE0-6ECB-07AD27847054}"/>
           </ac:spMkLst>
         </pc:spChg>
-        <pc:picChg chg="add del mod">
-          <ac:chgData name="Savannah Karin Miller" userId="22c948fc-cece-4b89-9db3-f9f8a6b29aef" providerId="ADAL" clId="{39DE2C0E-7095-495B-81F3-37AFAFAFC50B}" dt="2026-08-12T14:37:43.505" v="180" actId="478"/>
-          <ac:picMkLst>
-            <pc:docMk/>
-            <pc:sldMk cId="149973421" sldId="261"/>
-            <ac:picMk id="5" creationId="{D4CACD47-B1B8-8384-4D2C-EA7CA8A6D703}"/>
-          </ac:picMkLst>
-        </pc:picChg>
-        <pc:picChg chg="add mod">
-          <ac:chgData name="Savannah Karin Miller" userId="22c948fc-cece-4b89-9db3-f9f8a6b29aef" providerId="ADAL" clId="{39DE2C0E-7095-495B-81F3-37AFAFAFC50B}" dt="2026-08-12T14:41:09.339" v="200" actId="14100"/>
-          <ac:picMkLst>
-            <pc:docMk/>
-            <pc:sldMk cId="149973421" sldId="261"/>
-            <ac:picMk id="7" creationId="{F7832261-D5EA-1DDA-28F0-A408CE743E91}"/>
-          </ac:picMkLst>
-        </pc:picChg>
       </pc:sldChg>
       <pc:sldChg chg="modSp mod">
         <pc:chgData name="Savannah Karin Miller" userId="22c948fc-cece-4b89-9db3-f9f8a6b29aef" providerId="ADAL" clId="{39DE2C0E-7095-495B-81F3-37AFAFAFC50B}" dt="2026-08-12T18:42:32.101" v="937" actId="20577"/>
@@ -333,22 +352,6 @@
             <ac:spMk id="4" creationId="{113E0892-5338-514C-60B8-756FC7E8B649}"/>
           </ac:spMkLst>
         </pc:spChg>
-        <pc:picChg chg="del mod">
-          <ac:chgData name="Savannah Karin Miller" userId="22c948fc-cece-4b89-9db3-f9f8a6b29aef" providerId="ADAL" clId="{39DE2C0E-7095-495B-81F3-37AFAFAFC50B}" dt="2026-08-12T18:24:03.035" v="381" actId="478"/>
-          <ac:picMkLst>
-            <pc:docMk/>
-            <pc:sldMk cId="4265405073" sldId="264"/>
-            <ac:picMk id="5" creationId="{51829DA9-6DD1-9A17-65C8-4FAF156D442A}"/>
-          </ac:picMkLst>
-        </pc:picChg>
-        <pc:picChg chg="del">
-          <ac:chgData name="Savannah Karin Miller" userId="22c948fc-cece-4b89-9db3-f9f8a6b29aef" providerId="ADAL" clId="{39DE2C0E-7095-495B-81F3-37AFAFAFC50B}" dt="2026-08-12T18:14:55.275" v="232" actId="478"/>
-          <ac:picMkLst>
-            <pc:docMk/>
-            <pc:sldMk cId="4265405073" sldId="264"/>
-            <ac:picMk id="7" creationId="{D1A888EB-7CDE-B508-FD8E-C1AD5CAE6134}"/>
-          </ac:picMkLst>
-        </pc:picChg>
         <pc:picChg chg="add mod">
           <ac:chgData name="Savannah Karin Miller" userId="22c948fc-cece-4b89-9db3-f9f8a6b29aef" providerId="ADAL" clId="{39DE2C0E-7095-495B-81F3-37AFAFAFC50B}" dt="2026-08-12T18:33:51.144" v="622" actId="1076"/>
           <ac:picMkLst>
@@ -373,28 +376,81 @@
           </ac:spMkLst>
         </pc:spChg>
       </pc:sldChg>
-      <pc:sldChg chg="modSp mod">
-        <pc:chgData name="Savannah Karin Miller" userId="22c948fc-cece-4b89-9db3-f9f8a6b29aef" providerId="ADAL" clId="{39DE2C0E-7095-495B-81F3-37AFAFAFC50B}" dt="2026-08-12T18:12:58.573" v="227" actId="1076"/>
+      <pc:sldChg chg="modSp del mod">
+        <pc:chgData name="Savannah Karin Miller" userId="22c948fc-cece-4b89-9db3-f9f8a6b29aef" providerId="ADAL" clId="{39DE2C0E-7095-495B-81F3-37AFAFAFC50B}" dt="2026-08-20T04:03:19.984" v="962" actId="2696"/>
         <pc:sldMkLst>
           <pc:docMk/>
           <pc:sldMk cId="1052528304" sldId="266"/>
         </pc:sldMkLst>
+      </pc:sldChg>
+      <pc:sldChg chg="addSp delSp modSp add mod ord">
+        <pc:chgData name="Savannah Karin Miller" userId="22c948fc-cece-4b89-9db3-f9f8a6b29aef" providerId="ADAL" clId="{39DE2C0E-7095-495B-81F3-37AFAFAFC50B}" dt="2026-08-20T05:24:40.595" v="1437"/>
+        <pc:sldMkLst>
+          <pc:docMk/>
+          <pc:sldMk cId="1405136645" sldId="266"/>
+        </pc:sldMkLst>
+        <pc:spChg chg="del">
+          <ac:chgData name="Savannah Karin Miller" userId="22c948fc-cece-4b89-9db3-f9f8a6b29aef" providerId="ADAL" clId="{39DE2C0E-7095-495B-81F3-37AFAFAFC50B}" dt="2026-08-20T04:07:35.258" v="1147" actId="478"/>
+          <ac:spMkLst>
+            <pc:docMk/>
+            <pc:sldMk cId="1405136645" sldId="266"/>
+            <ac:spMk id="2" creationId="{43389EDE-6E73-950C-728E-C9304FEE2ADF}"/>
+          </ac:spMkLst>
+        </pc:spChg>
+        <pc:spChg chg="add del mod">
+          <ac:chgData name="Savannah Karin Miller" userId="22c948fc-cece-4b89-9db3-f9f8a6b29aef" providerId="ADAL" clId="{39DE2C0E-7095-495B-81F3-37AFAFAFC50B}" dt="2026-08-20T04:07:53.397" v="1151" actId="478"/>
+          <ac:spMkLst>
+            <pc:docMk/>
+            <pc:sldMk cId="1405136645" sldId="266"/>
+            <ac:spMk id="3" creationId="{BB1E39E0-A2A7-039C-EC56-05529E1FD783}"/>
+          </ac:spMkLst>
+        </pc:spChg>
+        <pc:spChg chg="add mod">
+          <ac:chgData name="Savannah Karin Miller" userId="22c948fc-cece-4b89-9db3-f9f8a6b29aef" providerId="ADAL" clId="{39DE2C0E-7095-495B-81F3-37AFAFAFC50B}" dt="2026-08-20T05:23:56.131" v="1415" actId="20577"/>
+          <ac:spMkLst>
+            <pc:docMk/>
+            <pc:sldMk cId="1405136645" sldId="266"/>
+            <ac:spMk id="5" creationId="{882C92FD-D86D-90B4-81AA-98FAAE246598}"/>
+          </ac:spMkLst>
+        </pc:spChg>
         <pc:picChg chg="mod">
-          <ac:chgData name="Savannah Karin Miller" userId="22c948fc-cece-4b89-9db3-f9f8a6b29aef" providerId="ADAL" clId="{39DE2C0E-7095-495B-81F3-37AFAFAFC50B}" dt="2026-08-12T18:12:50.547" v="225" actId="1076"/>
+          <ac:chgData name="Savannah Karin Miller" userId="22c948fc-cece-4b89-9db3-f9f8a6b29aef" providerId="ADAL" clId="{39DE2C0E-7095-495B-81F3-37AFAFAFC50B}" dt="2026-08-20T05:24:06.195" v="1422" actId="14100"/>
           <ac:picMkLst>
             <pc:docMk/>
-            <pc:sldMk cId="1052528304" sldId="266"/>
+            <pc:sldMk cId="1405136645" sldId="266"/>
             <ac:picMk id="13" creationId="{4C7567C2-EA05-EA38-EF7F-4F82C1F9E5D1}"/>
           </ac:picMkLst>
         </pc:picChg>
         <pc:picChg chg="mod">
-          <ac:chgData name="Savannah Karin Miller" userId="22c948fc-cece-4b89-9db3-f9f8a6b29aef" providerId="ADAL" clId="{39DE2C0E-7095-495B-81F3-37AFAFAFC50B}" dt="2026-08-12T18:12:58.573" v="227" actId="1076"/>
+          <ac:chgData name="Savannah Karin Miller" userId="22c948fc-cece-4b89-9db3-f9f8a6b29aef" providerId="ADAL" clId="{39DE2C0E-7095-495B-81F3-37AFAFAFC50B}" dt="2026-08-20T05:24:01.018" v="1418" actId="1076"/>
           <ac:picMkLst>
             <pc:docMk/>
-            <pc:sldMk cId="1052528304" sldId="266"/>
+            <pc:sldMk cId="1405136645" sldId="266"/>
             <ac:picMk id="17" creationId="{726B37FA-9DE5-3D3E-5230-48ABA774FB4D}"/>
           </ac:picMkLst>
         </pc:picChg>
+      </pc:sldChg>
+      <pc:sldChg chg="del">
+        <pc:chgData name="Savannah Karin Miller" userId="22c948fc-cece-4b89-9db3-f9f8a6b29aef" providerId="ADAL" clId="{39DE2C0E-7095-495B-81F3-37AFAFAFC50B}" dt="2026-08-20T04:03:19.984" v="962" actId="2696"/>
+        <pc:sldMkLst>
+          <pc:docMk/>
+          <pc:sldMk cId="486497429" sldId="267"/>
+        </pc:sldMkLst>
+      </pc:sldChg>
+      <pc:sldChg chg="modSp add mod ord">
+        <pc:chgData name="Savannah Karin Miller" userId="22c948fc-cece-4b89-9db3-f9f8a6b29aef" providerId="ADAL" clId="{39DE2C0E-7095-495B-81F3-37AFAFAFC50B}" dt="2026-08-20T04:07:02.200" v="1144"/>
+        <pc:sldMkLst>
+          <pc:docMk/>
+          <pc:sldMk cId="1610318545" sldId="267"/>
+        </pc:sldMkLst>
+        <pc:spChg chg="mod">
+          <ac:chgData name="Savannah Karin Miller" userId="22c948fc-cece-4b89-9db3-f9f8a6b29aef" providerId="ADAL" clId="{39DE2C0E-7095-495B-81F3-37AFAFAFC50B}" dt="2026-08-20T04:06:50.384" v="1142" actId="255"/>
+          <ac:spMkLst>
+            <pc:docMk/>
+            <pc:sldMk cId="1610318545" sldId="267"/>
+            <ac:spMk id="2" creationId="{828303BE-97E1-3299-8F4D-CD015365AE6C}"/>
+          </ac:spMkLst>
+        </pc:spChg>
       </pc:sldChg>
       <pc:sldChg chg="addSp delSp modSp add mod">
         <pc:chgData name="Savannah Karin Miller" userId="22c948fc-cece-4b89-9db3-f9f8a6b29aef" providerId="ADAL" clId="{39DE2C0E-7095-495B-81F3-37AFAFAFC50B}" dt="2026-08-12T18:12:11.679" v="222" actId="1076"/>
@@ -410,28 +466,12 @@
             <ac:spMk id="7" creationId="{49B09ACB-BE6D-7FFE-59B6-D654D93F4B1C}"/>
           </ac:spMkLst>
         </pc:spChg>
-        <pc:picChg chg="del">
-          <ac:chgData name="Savannah Karin Miller" userId="22c948fc-cece-4b89-9db3-f9f8a6b29aef" providerId="ADAL" clId="{39DE2C0E-7095-495B-81F3-37AFAFAFC50B}" dt="2026-08-12T00:04:40.012" v="44" actId="478"/>
-          <ac:picMkLst>
-            <pc:docMk/>
-            <pc:sldMk cId="1399441668" sldId="268"/>
-            <ac:picMk id="5" creationId="{6C0D3F00-3788-51BC-3DF3-FA91732D8197}"/>
-          </ac:picMkLst>
-        </pc:picChg>
         <pc:picChg chg="add mod">
           <ac:chgData name="Savannah Karin Miller" userId="22c948fc-cece-4b89-9db3-f9f8a6b29aef" providerId="ADAL" clId="{39DE2C0E-7095-495B-81F3-37AFAFAFC50B}" dt="2026-08-12T00:04:54.173" v="50" actId="1076"/>
           <ac:picMkLst>
             <pc:docMk/>
             <pc:sldMk cId="1399441668" sldId="268"/>
             <ac:picMk id="6" creationId="{B065BFEF-E75D-6D8C-C05E-070227D70229}"/>
-          </ac:picMkLst>
-        </pc:picChg>
-        <pc:picChg chg="del">
-          <ac:chgData name="Savannah Karin Miller" userId="22c948fc-cece-4b89-9db3-f9f8a6b29aef" providerId="ADAL" clId="{39DE2C0E-7095-495B-81F3-37AFAFAFC50B}" dt="2026-08-11T23:57:40.291" v="43" actId="478"/>
-          <ac:picMkLst>
-            <pc:docMk/>
-            <pc:sldMk cId="1399441668" sldId="268"/>
-            <ac:picMk id="9" creationId="{AF96B373-C10F-7310-2CA2-304CFFF0823E}"/>
           </ac:picMkLst>
         </pc:picChg>
         <pc:picChg chg="add mod">
@@ -444,29 +484,13 @@
         </pc:picChg>
       </pc:sldChg>
       <pc:sldChg chg="addSp delSp modSp add mod">
-        <pc:chgData name="Savannah Karin Miller" userId="22c948fc-cece-4b89-9db3-f9f8a6b29aef" providerId="ADAL" clId="{39DE2C0E-7095-495B-81F3-37AFAFAFC50B}" dt="2026-08-12T18:39:44.651" v="807" actId="1076"/>
+        <pc:chgData name="Savannah Karin Miller" userId="22c948fc-cece-4b89-9db3-f9f8a6b29aef" providerId="ADAL" clId="{39DE2C0E-7095-495B-81F3-37AFAFAFC50B}" dt="2026-08-20T04:05:33.282" v="1071" actId="1076"/>
         <pc:sldMkLst>
           <pc:docMk/>
           <pc:sldMk cId="214890209" sldId="269"/>
         </pc:sldMkLst>
-        <pc:spChg chg="add del mod">
-          <ac:chgData name="Savannah Karin Miller" userId="22c948fc-cece-4b89-9db3-f9f8a6b29aef" providerId="ADAL" clId="{39DE2C0E-7095-495B-81F3-37AFAFAFC50B}" dt="2026-08-12T18:36:14.557" v="628" actId="22"/>
-          <ac:spMkLst>
-            <pc:docMk/>
-            <pc:sldMk cId="214890209" sldId="269"/>
-            <ac:spMk id="4" creationId="{83CB0524-0B82-574B-0913-8617E2C4A4E6}"/>
-          </ac:spMkLst>
-        </pc:spChg>
-        <pc:spChg chg="add del mod">
-          <ac:chgData name="Savannah Karin Miller" userId="22c948fc-cece-4b89-9db3-f9f8a6b29aef" providerId="ADAL" clId="{39DE2C0E-7095-495B-81F3-37AFAFAFC50B}" dt="2026-08-12T18:36:50.986" v="630" actId="22"/>
-          <ac:spMkLst>
-            <pc:docMk/>
-            <pc:sldMk cId="214890209" sldId="269"/>
-            <ac:spMk id="6" creationId="{16DEB5C9-38E0-39DF-0398-D3AF9F512657}"/>
-          </ac:spMkLst>
-        </pc:spChg>
         <pc:spChg chg="add mod">
-          <ac:chgData name="Savannah Karin Miller" userId="22c948fc-cece-4b89-9db3-f9f8a6b29aef" providerId="ADAL" clId="{39DE2C0E-7095-495B-81F3-37AFAFAFC50B}" dt="2026-08-12T18:39:44.651" v="807" actId="1076"/>
+          <ac:chgData name="Savannah Karin Miller" userId="22c948fc-cece-4b89-9db3-f9f8a6b29aef" providerId="ADAL" clId="{39DE2C0E-7095-495B-81F3-37AFAFAFC50B}" dt="2026-08-20T04:05:26.125" v="1070" actId="1076"/>
           <ac:spMkLst>
             <pc:docMk/>
             <pc:sldMk cId="214890209" sldId="269"/>
@@ -474,19 +498,11 @@
           </ac:spMkLst>
         </pc:spChg>
         <pc:spChg chg="mod">
-          <ac:chgData name="Savannah Karin Miller" userId="22c948fc-cece-4b89-9db3-f9f8a6b29aef" providerId="ADAL" clId="{39DE2C0E-7095-495B-81F3-37AFAFAFC50B}" dt="2026-08-12T18:39:05.514" v="796" actId="1076"/>
+          <ac:chgData name="Savannah Karin Miller" userId="22c948fc-cece-4b89-9db3-f9f8a6b29aef" providerId="ADAL" clId="{39DE2C0E-7095-495B-81F3-37AFAFAFC50B}" dt="2026-08-20T04:05:33.282" v="1071" actId="1076"/>
           <ac:spMkLst>
             <pc:docMk/>
             <pc:sldMk cId="214890209" sldId="269"/>
             <ac:spMk id="17" creationId="{4EB98CC4-6474-69BA-B57B-1FCDF0E15445}"/>
-          </ac:spMkLst>
-        </pc:spChg>
-        <pc:spChg chg="del">
-          <ac:chgData name="Savannah Karin Miller" userId="22c948fc-cece-4b89-9db3-f9f8a6b29aef" providerId="ADAL" clId="{39DE2C0E-7095-495B-81F3-37AFAFAFC50B}" dt="2026-08-12T18:36:56.901" v="632" actId="478"/>
-          <ac:spMkLst>
-            <pc:docMk/>
-            <pc:sldMk cId="214890209" sldId="269"/>
-            <ac:spMk id="19" creationId="{0881FDFC-988A-BC64-C2E0-D1185F54D9F9}"/>
           </ac:spMkLst>
         </pc:spChg>
         <pc:spChg chg="add mod">
@@ -498,7 +514,7 @@
           </ac:spMkLst>
         </pc:spChg>
         <pc:picChg chg="add mod ord">
-          <ac:chgData name="Savannah Karin Miller" userId="22c948fc-cece-4b89-9db3-f9f8a6b29aef" providerId="ADAL" clId="{39DE2C0E-7095-495B-81F3-37AFAFAFC50B}" dt="2026-08-12T18:39:40.634" v="806" actId="1076"/>
+          <ac:chgData name="Savannah Karin Miller" userId="22c948fc-cece-4b89-9db3-f9f8a6b29aef" providerId="ADAL" clId="{39DE2C0E-7095-495B-81F3-37AFAFAFC50B}" dt="2026-08-20T04:05:22.705" v="1069" actId="1076"/>
           <ac:picMkLst>
             <pc:docMk/>
             <pc:sldMk cId="214890209" sldId="269"/>
@@ -513,20 +529,413 @@
             <ac:picMk id="12" creationId="{C7CB1A22-F94B-B8CD-B067-182F02E62E01}"/>
           </ac:picMkLst>
         </pc:picChg>
+      </pc:sldChg>
+      <pc:sldChg chg="modSp add del mod">
+        <pc:chgData name="Savannah Karin Miller" userId="22c948fc-cece-4b89-9db3-f9f8a6b29aef" providerId="ADAL" clId="{39DE2C0E-7095-495B-81F3-37AFAFAFC50B}" dt="2026-08-20T04:15:32.280" v="1401" actId="2696"/>
+        <pc:sldMkLst>
+          <pc:docMk/>
+          <pc:sldMk cId="341396645" sldId="270"/>
+        </pc:sldMkLst>
+        <pc:spChg chg="mod">
+          <ac:chgData name="Savannah Karin Miller" userId="22c948fc-cece-4b89-9db3-f9f8a6b29aef" providerId="ADAL" clId="{39DE2C0E-7095-495B-81F3-37AFAFAFC50B}" dt="2026-08-20T04:15:27.026" v="1400" actId="20577"/>
+          <ac:spMkLst>
+            <pc:docMk/>
+            <pc:sldMk cId="341396645" sldId="270"/>
+            <ac:spMk id="3" creationId="{644CA321-B9A3-F53E-0488-996968F4115A}"/>
+          </ac:spMkLst>
+        </pc:spChg>
+      </pc:sldChg>
+      <pc:sldChg chg="addSp delSp modSp add mod setBg addAnim delAnim">
+        <pc:chgData name="Savannah Karin Miller" userId="22c948fc-cece-4b89-9db3-f9f8a6b29aef" providerId="ADAL" clId="{39DE2C0E-7095-495B-81F3-37AFAFAFC50B}" dt="2026-08-20T04:14:53.975" v="1386" actId="20577"/>
+        <pc:sldMkLst>
+          <pc:docMk/>
+          <pc:sldMk cId="1111395093" sldId="271"/>
+        </pc:sldMkLst>
+        <pc:spChg chg="mod">
+          <ac:chgData name="Savannah Karin Miller" userId="22c948fc-cece-4b89-9db3-f9f8a6b29aef" providerId="ADAL" clId="{39DE2C0E-7095-495B-81F3-37AFAFAFC50B}" dt="2026-08-20T04:14:14.678" v="1321" actId="255"/>
+          <ac:spMkLst>
+            <pc:docMk/>
+            <pc:sldMk cId="1111395093" sldId="271"/>
+            <ac:spMk id="2" creationId="{835E6846-7F90-41CF-AB87-E4E17A756E9C}"/>
+          </ac:spMkLst>
+        </pc:spChg>
+        <pc:spChg chg="del mod">
+          <ac:chgData name="Savannah Karin Miller" userId="22c948fc-cece-4b89-9db3-f9f8a6b29aef" providerId="ADAL" clId="{39DE2C0E-7095-495B-81F3-37AFAFAFC50B}" dt="2026-08-20T04:14:19.305" v="1322" actId="478"/>
+          <ac:spMkLst>
+            <pc:docMk/>
+            <pc:sldMk cId="1111395093" sldId="271"/>
+            <ac:spMk id="3" creationId="{9454E0A5-FD7B-4359-3D99-DBA8ADA36504}"/>
+          </ac:spMkLst>
+        </pc:spChg>
+        <pc:spChg chg="add del mod">
+          <ac:chgData name="Savannah Karin Miller" userId="22c948fc-cece-4b89-9db3-f9f8a6b29aef" providerId="ADAL" clId="{39DE2C0E-7095-495B-81F3-37AFAFAFC50B}" dt="2026-08-20T04:09:35.778" v="1201" actId="478"/>
+          <ac:spMkLst>
+            <pc:docMk/>
+            <pc:sldMk cId="1111395093" sldId="271"/>
+            <ac:spMk id="5" creationId="{21F44FA3-E097-5EC2-5A1F-20EF7D73C7F0}"/>
+          </ac:spMkLst>
+        </pc:spChg>
+        <pc:spChg chg="add mod">
+          <ac:chgData name="Savannah Karin Miller" userId="22c948fc-cece-4b89-9db3-f9f8a6b29aef" providerId="ADAL" clId="{39DE2C0E-7095-495B-81F3-37AFAFAFC50B}" dt="2026-08-20T04:14:22.759" v="1323" actId="113"/>
+          <ac:spMkLst>
+            <pc:docMk/>
+            <pc:sldMk cId="1111395093" sldId="271"/>
+            <ac:spMk id="12" creationId="{559984F5-70D9-812F-90FE-1F2FAF1A0BFF}"/>
+          </ac:spMkLst>
+        </pc:spChg>
+        <pc:spChg chg="add del">
+          <ac:chgData name="Savannah Karin Miller" userId="22c948fc-cece-4b89-9db3-f9f8a6b29aef" providerId="ADAL" clId="{39DE2C0E-7095-495B-81F3-37AFAFAFC50B}" dt="2026-08-20T04:12:55.882" v="1249" actId="26606"/>
+          <ac:spMkLst>
+            <pc:docMk/>
+            <pc:sldMk cId="1111395093" sldId="271"/>
+            <ac:spMk id="15" creationId="{0A597D97-203B-498B-95D3-E90DC961039F}"/>
+          </ac:spMkLst>
+        </pc:spChg>
+        <pc:spChg chg="add mod">
+          <ac:chgData name="Savannah Karin Miller" userId="22c948fc-cece-4b89-9db3-f9f8a6b29aef" providerId="ADAL" clId="{39DE2C0E-7095-495B-81F3-37AFAFAFC50B}" dt="2026-08-20T04:14:53.975" v="1386" actId="20577"/>
+          <ac:spMkLst>
+            <pc:docMk/>
+            <pc:sldMk cId="1111395093" sldId="271"/>
+            <ac:spMk id="16" creationId="{B906DF8C-8A46-E58E-A72D-FAE9A6358388}"/>
+          </ac:spMkLst>
+        </pc:spChg>
+        <pc:spChg chg="add del">
+          <ac:chgData name="Savannah Karin Miller" userId="22c948fc-cece-4b89-9db3-f9f8a6b29aef" providerId="ADAL" clId="{39DE2C0E-7095-495B-81F3-37AFAFAFC50B}" dt="2026-08-20T04:12:55.882" v="1249" actId="26606"/>
+          <ac:spMkLst>
+            <pc:docMk/>
+            <pc:sldMk cId="1111395093" sldId="271"/>
+            <ac:spMk id="17" creationId="{6A6EF10E-DF41-4BD3-8EB4-6F646531DC26}"/>
+          </ac:spMkLst>
+        </pc:spChg>
         <pc:picChg chg="del">
-          <ac:chgData name="Savannah Karin Miller" userId="22c948fc-cece-4b89-9db3-f9f8a6b29aef" providerId="ADAL" clId="{39DE2C0E-7095-495B-81F3-37AFAFAFC50B}" dt="2026-08-12T18:34:25.209" v="626" actId="478"/>
+          <ac:chgData name="Savannah Karin Miller" userId="22c948fc-cece-4b89-9db3-f9f8a6b29aef" providerId="ADAL" clId="{39DE2C0E-7095-495B-81F3-37AFAFAFC50B}" dt="2026-08-20T04:09:36.718" v="1202" actId="478"/>
           <ac:picMkLst>
             <pc:docMk/>
-            <pc:sldMk cId="214890209" sldId="269"/>
-            <ac:picMk id="13" creationId="{A1D42737-9687-B840-5D99-F6D648EE654D}"/>
+            <pc:sldMk cId="1111395093" sldId="271"/>
+            <ac:picMk id="7" creationId="{6DCCF49A-834C-6855-9731-213787184B8A}"/>
+          </ac:picMkLst>
+        </pc:picChg>
+        <pc:picChg chg="add mod ord modCrop">
+          <ac:chgData name="Savannah Karin Miller" userId="22c948fc-cece-4b89-9db3-f9f8a6b29aef" providerId="ADAL" clId="{39DE2C0E-7095-495B-81F3-37AFAFAFC50B}" dt="2026-08-20T04:13:16.189" v="1253" actId="1076"/>
+          <ac:picMkLst>
+            <pc:docMk/>
+            <pc:sldMk cId="1111395093" sldId="271"/>
+            <ac:picMk id="8" creationId="{F9B62FE9-BE28-E814-3362-D04504F36D6C}"/>
+          </ac:picMkLst>
+        </pc:picChg>
+        <pc:picChg chg="add mod ord modCrop">
+          <ac:chgData name="Savannah Karin Miller" userId="22c948fc-cece-4b89-9db3-f9f8a6b29aef" providerId="ADAL" clId="{39DE2C0E-7095-495B-81F3-37AFAFAFC50B}" dt="2026-08-20T04:13:18.986" v="1254" actId="14100"/>
+          <ac:picMkLst>
+            <pc:docMk/>
+            <pc:sldMk cId="1111395093" sldId="271"/>
+            <ac:picMk id="10" creationId="{89BEF38C-8DD8-0242-73CB-3542E5DA72E7}"/>
           </ac:picMkLst>
         </pc:picChg>
         <pc:picChg chg="del">
-          <ac:chgData name="Savannah Karin Miller" userId="22c948fc-cece-4b89-9db3-f9f8a6b29aef" providerId="ADAL" clId="{39DE2C0E-7095-495B-81F3-37AFAFAFC50B}" dt="2026-08-12T18:34:26.795" v="627" actId="478"/>
+          <ac:chgData name="Savannah Karin Miller" userId="22c948fc-cece-4b89-9db3-f9f8a6b29aef" providerId="ADAL" clId="{39DE2C0E-7095-495B-81F3-37AFAFAFC50B}" dt="2026-08-20T04:09:29.967" v="1200" actId="478"/>
           <ac:picMkLst>
             <pc:docMk/>
-            <pc:sldMk cId="214890209" sldId="269"/>
-            <ac:picMk id="15" creationId="{7CE25BC2-F317-B41A-5C4B-B5B0A5ACD0E3}"/>
+            <pc:sldMk cId="1111395093" sldId="271"/>
+            <ac:picMk id="11" creationId="{E6F10AFD-E4E2-D1CA-65F5-1B9B1CA18A78}"/>
+          </ac:picMkLst>
+        </pc:picChg>
+        <pc:picChg chg="add">
+          <ac:chgData name="Savannah Karin Miller" userId="22c948fc-cece-4b89-9db3-f9f8a6b29aef" providerId="ADAL" clId="{39DE2C0E-7095-495B-81F3-37AFAFAFC50B}" dt="2026-08-20T04:14:25.434" v="1324"/>
+          <ac:picMkLst>
+            <pc:docMk/>
+            <pc:sldMk cId="1111395093" sldId="271"/>
+            <ac:picMk id="13" creationId="{40B1F902-6574-AA0A-4FA0-369A2038EFE8}"/>
+          </ac:picMkLst>
+        </pc:picChg>
+      </pc:sldChg>
+      <pc:sldChg chg="addSp delSp modSp add mod modClrScheme chgLayout">
+        <pc:chgData name="Savannah Karin Miller" userId="22c948fc-cece-4b89-9db3-f9f8a6b29aef" providerId="ADAL" clId="{39DE2C0E-7095-495B-81F3-37AFAFAFC50B}" dt="2026-08-20T05:36:49.413" v="1457" actId="14100"/>
+        <pc:sldMkLst>
+          <pc:docMk/>
+          <pc:sldMk cId="60502188" sldId="272"/>
+        </pc:sldMkLst>
+        <pc:spChg chg="add del mod ord">
+          <ac:chgData name="Savannah Karin Miller" userId="22c948fc-cece-4b89-9db3-f9f8a6b29aef" providerId="ADAL" clId="{39DE2C0E-7095-495B-81F3-37AFAFAFC50B}" dt="2026-08-20T05:35:15.835" v="1438" actId="700"/>
+          <ac:spMkLst>
+            <pc:docMk/>
+            <pc:sldMk cId="60502188" sldId="272"/>
+            <ac:spMk id="3" creationId="{E9AC543D-A4AF-99C7-F78A-28A23A2F5917}"/>
+          </ac:spMkLst>
+        </pc:spChg>
+        <pc:spChg chg="add del mod ord">
+          <ac:chgData name="Savannah Karin Miller" userId="22c948fc-cece-4b89-9db3-f9f8a6b29aef" providerId="ADAL" clId="{39DE2C0E-7095-495B-81F3-37AFAFAFC50B}" dt="2026-08-20T05:35:46.065" v="1439" actId="931"/>
+          <ac:spMkLst>
+            <pc:docMk/>
+            <pc:sldMk cId="60502188" sldId="272"/>
+            <ac:spMk id="4" creationId="{607748A0-0D2E-B603-A571-80FF43DB40A7}"/>
+          </ac:spMkLst>
+        </pc:spChg>
+        <pc:spChg chg="mod ord">
+          <ac:chgData name="Savannah Karin Miller" userId="22c948fc-cece-4b89-9db3-f9f8a6b29aef" providerId="ADAL" clId="{39DE2C0E-7095-495B-81F3-37AFAFAFC50B}" dt="2026-08-20T05:35:15.835" v="1438" actId="700"/>
+          <ac:spMkLst>
+            <pc:docMk/>
+            <pc:sldMk cId="60502188" sldId="272"/>
+            <ac:spMk id="5" creationId="{1AC1C78C-F114-9F03-CABB-D1F643B2F9CF}"/>
+          </ac:spMkLst>
+        </pc:spChg>
+        <pc:spChg chg="add del mod ord">
+          <ac:chgData name="Savannah Karin Miller" userId="22c948fc-cece-4b89-9db3-f9f8a6b29aef" providerId="ADAL" clId="{39DE2C0E-7095-495B-81F3-37AFAFAFC50B}" dt="2026-08-20T05:35:59.198" v="1440" actId="931"/>
+          <ac:spMkLst>
+            <pc:docMk/>
+            <pc:sldMk cId="60502188" sldId="272"/>
+            <ac:spMk id="6" creationId="{3186932C-9F49-76AD-B4E0-DDAF2877D42A}"/>
+          </ac:spMkLst>
+        </pc:spChg>
+        <pc:spChg chg="add del mod">
+          <ac:chgData name="Savannah Karin Miller" userId="22c948fc-cece-4b89-9db3-f9f8a6b29aef" providerId="ADAL" clId="{39DE2C0E-7095-495B-81F3-37AFAFAFC50B}" dt="2026-08-20T05:36:25.047" v="1446" actId="478"/>
+          <ac:spMkLst>
+            <pc:docMk/>
+            <pc:sldMk cId="60502188" sldId="272"/>
+            <ac:spMk id="12" creationId="{31A2B2D6-2976-1855-87BD-9E52C8A6B072}"/>
+          </ac:spMkLst>
+        </pc:spChg>
+        <pc:picChg chg="add mod ord">
+          <ac:chgData name="Savannah Karin Miller" userId="22c948fc-cece-4b89-9db3-f9f8a6b29aef" providerId="ADAL" clId="{39DE2C0E-7095-495B-81F3-37AFAFAFC50B}" dt="2026-08-20T05:36:49.413" v="1457" actId="14100"/>
+          <ac:picMkLst>
+            <pc:docMk/>
+            <pc:sldMk cId="60502188" sldId="272"/>
+            <ac:picMk id="8" creationId="{C92C93C1-B35A-EFBF-A16F-4E639ADB4BF1}"/>
+          </ac:picMkLst>
+        </pc:picChg>
+        <pc:picChg chg="add del mod ord">
+          <ac:chgData name="Savannah Karin Miller" userId="22c948fc-cece-4b89-9db3-f9f8a6b29aef" providerId="ADAL" clId="{39DE2C0E-7095-495B-81F3-37AFAFAFC50B}" dt="2026-08-20T05:36:05.481" v="1441" actId="21"/>
+          <ac:picMkLst>
+            <pc:docMk/>
+            <pc:sldMk cId="60502188" sldId="272"/>
+            <ac:picMk id="10" creationId="{68FFCE07-947D-76F5-B7E1-A3DA6781E01E}"/>
+          </ac:picMkLst>
+        </pc:picChg>
+        <pc:picChg chg="del">
+          <ac:chgData name="Savannah Karin Miller" userId="22c948fc-cece-4b89-9db3-f9f8a6b29aef" providerId="ADAL" clId="{39DE2C0E-7095-495B-81F3-37AFAFAFC50B}" dt="2026-08-20T05:24:37.370" v="1435" actId="478"/>
+          <ac:picMkLst>
+            <pc:docMk/>
+            <pc:sldMk cId="60502188" sldId="272"/>
+            <ac:picMk id="13" creationId="{C4973166-E5A0-D9A1-80C1-0D9EB39ECC5E}"/>
+          </ac:picMkLst>
+        </pc:picChg>
+        <pc:picChg chg="del">
+          <ac:chgData name="Savannah Karin Miller" userId="22c948fc-cece-4b89-9db3-f9f8a6b29aef" providerId="ADAL" clId="{39DE2C0E-7095-495B-81F3-37AFAFAFC50B}" dt="2026-08-20T05:24:34.601" v="1434" actId="478"/>
+          <ac:picMkLst>
+            <pc:docMk/>
+            <pc:sldMk cId="60502188" sldId="272"/>
+            <ac:picMk id="17" creationId="{6828F3C3-B3A2-7639-D53B-F7B62F8241A8}"/>
+          </ac:picMkLst>
+        </pc:picChg>
+      </pc:sldChg>
+      <pc:sldChg chg="addSp delSp modSp add mod ord">
+        <pc:chgData name="Savannah Karin Miller" userId="22c948fc-cece-4b89-9db3-f9f8a6b29aef" providerId="ADAL" clId="{39DE2C0E-7095-495B-81F3-37AFAFAFC50B}" dt="2026-08-20T05:43:59.900" v="1572"/>
+        <pc:sldMkLst>
+          <pc:docMk/>
+          <pc:sldMk cId="1423438856" sldId="273"/>
+        </pc:sldMkLst>
+        <pc:spChg chg="add del mod">
+          <ac:chgData name="Savannah Karin Miller" userId="22c948fc-cece-4b89-9db3-f9f8a6b29aef" providerId="ADAL" clId="{39DE2C0E-7095-495B-81F3-37AFAFAFC50B}" dt="2026-08-20T05:36:15.751" v="1444" actId="22"/>
+          <ac:spMkLst>
+            <pc:docMk/>
+            <pc:sldMk cId="1423438856" sldId="273"/>
+            <ac:spMk id="3" creationId="{2B76857D-685B-B798-7A5B-A0A8BB4D81D9}"/>
+          </ac:spMkLst>
+        </pc:spChg>
+        <pc:spChg chg="del">
+          <ac:chgData name="Savannah Karin Miller" userId="22c948fc-cece-4b89-9db3-f9f8a6b29aef" providerId="ADAL" clId="{39DE2C0E-7095-495B-81F3-37AFAFAFC50B}" dt="2026-08-20T05:36:20.210" v="1445" actId="478"/>
+          <ac:spMkLst>
+            <pc:docMk/>
+            <pc:sldMk cId="1423438856" sldId="273"/>
+            <ac:spMk id="12" creationId="{83A3D8E7-A676-BA05-039E-A1C614F56B13}"/>
+          </ac:spMkLst>
+        </pc:spChg>
+        <pc:picChg chg="add mod ord">
+          <ac:chgData name="Savannah Karin Miller" userId="22c948fc-cece-4b89-9db3-f9f8a6b29aef" providerId="ADAL" clId="{39DE2C0E-7095-495B-81F3-37AFAFAFC50B}" dt="2026-08-20T05:36:43.062" v="1454" actId="1076"/>
+          <ac:picMkLst>
+            <pc:docMk/>
+            <pc:sldMk cId="1423438856" sldId="273"/>
+            <ac:picMk id="6" creationId="{2DD3CF05-1033-5F10-ED03-2651C114977F}"/>
+          </ac:picMkLst>
+        </pc:picChg>
+        <pc:picChg chg="del">
+          <ac:chgData name="Savannah Karin Miller" userId="22c948fc-cece-4b89-9db3-f9f8a6b29aef" providerId="ADAL" clId="{39DE2C0E-7095-495B-81F3-37AFAFAFC50B}" dt="2026-08-20T05:36:12.626" v="1443" actId="478"/>
+          <ac:picMkLst>
+            <pc:docMk/>
+            <pc:sldMk cId="1423438856" sldId="273"/>
+            <ac:picMk id="8" creationId="{9957C1E1-349E-AB99-70D3-A43CDC0042DE}"/>
+          </ac:picMkLst>
+        </pc:picChg>
+      </pc:sldChg>
+      <pc:sldChg chg="new del">
+        <pc:chgData name="Savannah Karin Miller" userId="22c948fc-cece-4b89-9db3-f9f8a6b29aef" providerId="ADAL" clId="{39DE2C0E-7095-495B-81F3-37AFAFAFC50B}" dt="2026-08-20T05:36:58.959" v="1459" actId="680"/>
+        <pc:sldMkLst>
+          <pc:docMk/>
+          <pc:sldMk cId="706961246" sldId="274"/>
+        </pc:sldMkLst>
+      </pc:sldChg>
+      <pc:sldChg chg="addSp delSp modSp add mod chgLayout">
+        <pc:chgData name="Savannah Karin Miller" userId="22c948fc-cece-4b89-9db3-f9f8a6b29aef" providerId="ADAL" clId="{39DE2C0E-7095-495B-81F3-37AFAFAFC50B}" dt="2026-08-20T05:45:03.552" v="1573" actId="1076"/>
+        <pc:sldMkLst>
+          <pc:docMk/>
+          <pc:sldMk cId="2014083808" sldId="274"/>
+        </pc:sldMkLst>
+        <pc:spChg chg="add del mod">
+          <ac:chgData name="Savannah Karin Miller" userId="22c948fc-cece-4b89-9db3-f9f8a6b29aef" providerId="ADAL" clId="{39DE2C0E-7095-495B-81F3-37AFAFAFC50B}" dt="2026-08-20T05:37:09.493" v="1462" actId="700"/>
+          <ac:spMkLst>
+            <pc:docMk/>
+            <pc:sldMk cId="2014083808" sldId="274"/>
+            <ac:spMk id="3" creationId="{EC892FE6-9889-D30E-EFA0-4ECB05C99373}"/>
+          </ac:spMkLst>
+        </pc:spChg>
+        <pc:spChg chg="add del mod ord">
+          <ac:chgData name="Savannah Karin Miller" userId="22c948fc-cece-4b89-9db3-f9f8a6b29aef" providerId="ADAL" clId="{39DE2C0E-7095-495B-81F3-37AFAFAFC50B}" dt="2026-08-20T05:37:25.624" v="1463" actId="931"/>
+          <ac:spMkLst>
+            <pc:docMk/>
+            <pc:sldMk cId="2014083808" sldId="274"/>
+            <ac:spMk id="4" creationId="{23B70E15-CD13-E0DE-5C9F-E51F359FC561}"/>
+          </ac:spMkLst>
+        </pc:spChg>
+        <pc:spChg chg="mod ord">
+          <ac:chgData name="Savannah Karin Miller" userId="22c948fc-cece-4b89-9db3-f9f8a6b29aef" providerId="ADAL" clId="{39DE2C0E-7095-495B-81F3-37AFAFAFC50B}" dt="2026-08-20T05:39:00.092" v="1468" actId="1076"/>
+          <ac:spMkLst>
+            <pc:docMk/>
+            <pc:sldMk cId="2014083808" sldId="274"/>
+            <ac:spMk id="5" creationId="{A33E62B1-48AB-68EA-CB4F-5AB9099C19C1}"/>
+          </ac:spMkLst>
+        </pc:spChg>
+        <pc:spChg chg="add del mod ord">
+          <ac:chgData name="Savannah Karin Miller" userId="22c948fc-cece-4b89-9db3-f9f8a6b29aef" providerId="ADAL" clId="{39DE2C0E-7095-495B-81F3-37AFAFAFC50B}" dt="2026-08-20T05:38:03.995" v="1466" actId="931"/>
+          <ac:spMkLst>
+            <pc:docMk/>
+            <pc:sldMk cId="2014083808" sldId="274"/>
+            <ac:spMk id="7" creationId="{70B93B27-0C15-61C2-CAA9-1CFE3DA84C7B}"/>
+          </ac:spMkLst>
+        </pc:spChg>
+        <pc:spChg chg="add mod">
+          <ac:chgData name="Savannah Karin Miller" userId="22c948fc-cece-4b89-9db3-f9f8a6b29aef" providerId="ADAL" clId="{39DE2C0E-7095-495B-81F3-37AFAFAFC50B}" dt="2026-08-20T05:45:03.552" v="1573" actId="1076"/>
+          <ac:spMkLst>
+            <pc:docMk/>
+            <pc:sldMk cId="2014083808" sldId="274"/>
+            <ac:spMk id="14" creationId="{A6364580-F88B-1990-D4B7-7AAC60649506}"/>
+          </ac:spMkLst>
+        </pc:spChg>
+        <pc:spChg chg="add del mod">
+          <ac:chgData name="Savannah Karin Miller" userId="22c948fc-cece-4b89-9db3-f9f8a6b29aef" providerId="ADAL" clId="{39DE2C0E-7095-495B-81F3-37AFAFAFC50B}" dt="2026-08-20T05:41:37.765" v="1543" actId="478"/>
+          <ac:spMkLst>
+            <pc:docMk/>
+            <pc:sldMk cId="2014083808" sldId="274"/>
+            <ac:spMk id="16" creationId="{92A2E67C-682C-43FF-A661-1FAA23984D40}"/>
+          </ac:spMkLst>
+        </pc:spChg>
+        <pc:spChg chg="add del mod">
+          <ac:chgData name="Savannah Karin Miller" userId="22c948fc-cece-4b89-9db3-f9f8a6b29aef" providerId="ADAL" clId="{39DE2C0E-7095-495B-81F3-37AFAFAFC50B}" dt="2026-08-20T05:41:39.185" v="1544" actId="478"/>
+          <ac:spMkLst>
+            <pc:docMk/>
+            <pc:sldMk cId="2014083808" sldId="274"/>
+            <ac:spMk id="20" creationId="{217E0A54-3918-23E0-BCD9-7488579C2237}"/>
+          </ac:spMkLst>
+        </pc:spChg>
+        <pc:picChg chg="del">
+          <ac:chgData name="Savannah Karin Miller" userId="22c948fc-cece-4b89-9db3-f9f8a6b29aef" providerId="ADAL" clId="{39DE2C0E-7095-495B-81F3-37AFAFAFC50B}" dt="2026-08-20T05:37:05.523" v="1461" actId="478"/>
+          <ac:picMkLst>
+            <pc:docMk/>
+            <pc:sldMk cId="2014083808" sldId="274"/>
+            <ac:picMk id="6" creationId="{7A6DBA27-CEDB-86E1-DA4D-7EDCE1870D4A}"/>
+          </ac:picMkLst>
+        </pc:picChg>
+        <pc:picChg chg="add mod ord">
+          <ac:chgData name="Savannah Karin Miller" userId="22c948fc-cece-4b89-9db3-f9f8a6b29aef" providerId="ADAL" clId="{39DE2C0E-7095-495B-81F3-37AFAFAFC50B}" dt="2026-08-20T05:43:25.455" v="1563" actId="1076"/>
+          <ac:picMkLst>
+            <pc:docMk/>
+            <pc:sldMk cId="2014083808" sldId="274"/>
+            <ac:picMk id="9" creationId="{A8941919-1DF5-6728-17D0-5F1E0900DDF2}"/>
+          </ac:picMkLst>
+        </pc:picChg>
+        <pc:picChg chg="add del mod ord">
+          <ac:chgData name="Savannah Karin Miller" userId="22c948fc-cece-4b89-9db3-f9f8a6b29aef" providerId="ADAL" clId="{39DE2C0E-7095-495B-81F3-37AFAFAFC50B}" dt="2026-08-20T05:37:55.244" v="1465" actId="931"/>
+          <ac:picMkLst>
+            <pc:docMk/>
+            <pc:sldMk cId="2014083808" sldId="274"/>
+            <ac:picMk id="11" creationId="{B3CA989C-6D2A-8DE3-3DF8-556037D46FF6}"/>
+          </ac:picMkLst>
+        </pc:picChg>
+        <pc:picChg chg="add del mod ord">
+          <ac:chgData name="Savannah Karin Miller" userId="22c948fc-cece-4b89-9db3-f9f8a6b29aef" providerId="ADAL" clId="{39DE2C0E-7095-495B-81F3-37AFAFAFC50B}" dt="2026-08-20T05:40:48.835" v="1528" actId="21"/>
+          <ac:picMkLst>
+            <pc:docMk/>
+            <pc:sldMk cId="2014083808" sldId="274"/>
+            <ac:picMk id="13" creationId="{026BEB35-102A-2A29-D00A-4CD510F7A397}"/>
+          </ac:picMkLst>
+        </pc:picChg>
+        <pc:picChg chg="add mod">
+          <ac:chgData name="Savannah Karin Miller" userId="22c948fc-cece-4b89-9db3-f9f8a6b29aef" providerId="ADAL" clId="{39DE2C0E-7095-495B-81F3-37AFAFAFC50B}" dt="2026-08-20T05:43:32.582" v="1565" actId="1076"/>
+          <ac:picMkLst>
+            <pc:docMk/>
+            <pc:sldMk cId="2014083808" sldId="274"/>
+            <ac:picMk id="18" creationId="{EAB29286-2DDD-2F18-5B92-1628567F20B6}"/>
+          </ac:picMkLst>
+        </pc:picChg>
+      </pc:sldChg>
+      <pc:sldChg chg="addSp delSp modSp add mod">
+        <pc:chgData name="Savannah Karin Miller" userId="22c948fc-cece-4b89-9db3-f9f8a6b29aef" providerId="ADAL" clId="{39DE2C0E-7095-495B-81F3-37AFAFAFC50B}" dt="2026-08-20T05:43:50.577" v="1570" actId="14100"/>
+        <pc:sldMkLst>
+          <pc:docMk/>
+          <pc:sldMk cId="4226288996" sldId="275"/>
+        </pc:sldMkLst>
+        <pc:spChg chg="add del mod">
+          <ac:chgData name="Savannah Karin Miller" userId="22c948fc-cece-4b89-9db3-f9f8a6b29aef" providerId="ADAL" clId="{39DE2C0E-7095-495B-81F3-37AFAFAFC50B}" dt="2026-08-20T05:40:58.162" v="1532" actId="478"/>
+          <ac:spMkLst>
+            <pc:docMk/>
+            <pc:sldMk cId="4226288996" sldId="275"/>
+            <ac:spMk id="3" creationId="{18F191AA-DF0A-7F44-6BE0-3863C7E80BD6}"/>
+          </ac:spMkLst>
+        </pc:spChg>
+        <pc:spChg chg="del">
+          <ac:chgData name="Savannah Karin Miller" userId="22c948fc-cece-4b89-9db3-f9f8a6b29aef" providerId="ADAL" clId="{39DE2C0E-7095-495B-81F3-37AFAFAFC50B}" dt="2026-08-20T05:40:54.343" v="1530" actId="478"/>
+          <ac:spMkLst>
+            <pc:docMk/>
+            <pc:sldMk cId="4226288996" sldId="275"/>
+            <ac:spMk id="14" creationId="{4E0F94C7-4B3E-D4BD-A0CD-D45960D85227}"/>
+          </ac:spMkLst>
+        </pc:spChg>
+        <pc:spChg chg="mod">
+          <ac:chgData name="Savannah Karin Miller" userId="22c948fc-cece-4b89-9db3-f9f8a6b29aef" providerId="ADAL" clId="{39DE2C0E-7095-495B-81F3-37AFAFAFC50B}" dt="2026-08-20T05:41:00.950" v="1533" actId="1076"/>
+          <ac:spMkLst>
+            <pc:docMk/>
+            <pc:sldMk cId="4226288996" sldId="275"/>
+            <ac:spMk id="16" creationId="{57744FFD-0BD5-B498-C937-661589C1A6F9}"/>
+          </ac:spMkLst>
+        </pc:spChg>
+        <pc:picChg chg="add mod">
+          <ac:chgData name="Savannah Karin Miller" userId="22c948fc-cece-4b89-9db3-f9f8a6b29aef" providerId="ADAL" clId="{39DE2C0E-7095-495B-81F3-37AFAFAFC50B}" dt="2026-08-20T05:43:50.577" v="1570" actId="14100"/>
+          <ac:picMkLst>
+            <pc:docMk/>
+            <pc:sldMk cId="4226288996" sldId="275"/>
+            <ac:picMk id="6" creationId="{4CF2DFB9-07CD-5B8A-A5BD-27032714F58D}"/>
+          </ac:picMkLst>
+        </pc:picChg>
+        <pc:picChg chg="del">
+          <ac:chgData name="Savannah Karin Miller" userId="22c948fc-cece-4b89-9db3-f9f8a6b29aef" providerId="ADAL" clId="{39DE2C0E-7095-495B-81F3-37AFAFAFC50B}" dt="2026-08-20T05:40:52.491" v="1529" actId="478"/>
+          <ac:picMkLst>
+            <pc:docMk/>
+            <pc:sldMk cId="4226288996" sldId="275"/>
+            <ac:picMk id="9" creationId="{AE4B7AEC-49C0-F8F3-44D6-AE2DC5AC4529}"/>
+          </ac:picMkLst>
+        </pc:picChg>
+        <pc:picChg chg="mod">
+          <ac:chgData name="Savannah Karin Miller" userId="22c948fc-cece-4b89-9db3-f9f8a6b29aef" providerId="ADAL" clId="{39DE2C0E-7095-495B-81F3-37AFAFAFC50B}" dt="2026-08-20T05:43:38.274" v="1566" actId="1076"/>
+          <ac:picMkLst>
+            <pc:docMk/>
+            <pc:sldMk cId="4226288996" sldId="275"/>
+            <ac:picMk id="13" creationId="{4C15FACB-80DB-3369-38CB-508717602E70}"/>
+          </ac:picMkLst>
+        </pc:picChg>
+        <pc:picChg chg="del">
+          <ac:chgData name="Savannah Karin Miller" userId="22c948fc-cece-4b89-9db3-f9f8a6b29aef" providerId="ADAL" clId="{39DE2C0E-7095-495B-81F3-37AFAFAFC50B}" dt="2026-08-20T05:40:56.460" v="1531" actId="478"/>
+          <ac:picMkLst>
+            <pc:docMk/>
+            <pc:sldMk cId="4226288996" sldId="275"/>
+            <ac:picMk id="18" creationId="{F42DFC4E-88DD-9DB5-C650-B4BC36AFE700}"/>
           </ac:picMkLst>
         </pc:picChg>
       </pc:sldChg>
@@ -682,7 +1091,7 @@
           <a:p>
             <a:fld id="{36125577-04C1-4DFE-9495-826892B20392}" type="datetimeFigureOut">
               <a:rPr lang="en-US" smtClean="0"/>
-              <a:t>8/12/2026</a:t>
+              <a:t>8/19/2026</a:t>
             </a:fld>
             <a:endParaRPr lang="en-US"/>
           </a:p>
@@ -880,7 +1289,7 @@
           <a:p>
             <a:fld id="{36125577-04C1-4DFE-9495-826892B20392}" type="datetimeFigureOut">
               <a:rPr lang="en-US" smtClean="0"/>
-              <a:t>8/12/2026</a:t>
+              <a:t>8/19/2026</a:t>
             </a:fld>
             <a:endParaRPr lang="en-US"/>
           </a:p>
@@ -1088,7 +1497,7 @@
           <a:p>
             <a:fld id="{36125577-04C1-4DFE-9495-826892B20392}" type="datetimeFigureOut">
               <a:rPr lang="en-US" smtClean="0"/>
-              <a:t>8/12/2026</a:t>
+              <a:t>8/19/2026</a:t>
             </a:fld>
             <a:endParaRPr lang="en-US"/>
           </a:p>
@@ -1286,7 +1695,7 @@
           <a:p>
             <a:fld id="{36125577-04C1-4DFE-9495-826892B20392}" type="datetimeFigureOut">
               <a:rPr lang="en-US" smtClean="0"/>
-              <a:t>8/12/2026</a:t>
+              <a:t>8/19/2026</a:t>
             </a:fld>
             <a:endParaRPr lang="en-US"/>
           </a:p>
@@ -1561,7 +1970,7 @@
           <a:p>
             <a:fld id="{36125577-04C1-4DFE-9495-826892B20392}" type="datetimeFigureOut">
               <a:rPr lang="en-US" smtClean="0"/>
-              <a:t>8/12/2026</a:t>
+              <a:t>8/19/2026</a:t>
             </a:fld>
             <a:endParaRPr lang="en-US"/>
           </a:p>
@@ -1826,7 +2235,7 @@
           <a:p>
             <a:fld id="{36125577-04C1-4DFE-9495-826892B20392}" type="datetimeFigureOut">
               <a:rPr lang="en-US" smtClean="0"/>
-              <a:t>8/12/2026</a:t>
+              <a:t>8/19/2026</a:t>
             </a:fld>
             <a:endParaRPr lang="en-US"/>
           </a:p>
@@ -2238,7 +2647,7 @@
           <a:p>
             <a:fld id="{36125577-04C1-4DFE-9495-826892B20392}" type="datetimeFigureOut">
               <a:rPr lang="en-US" smtClean="0"/>
-              <a:t>8/12/2026</a:t>
+              <a:t>8/19/2026</a:t>
             </a:fld>
             <a:endParaRPr lang="en-US"/>
           </a:p>
@@ -2379,7 +2788,7 @@
           <a:p>
             <a:fld id="{36125577-04C1-4DFE-9495-826892B20392}" type="datetimeFigureOut">
               <a:rPr lang="en-US" smtClean="0"/>
-              <a:t>8/12/2026</a:t>
+              <a:t>8/19/2026</a:t>
             </a:fld>
             <a:endParaRPr lang="en-US"/>
           </a:p>
@@ -2492,7 +2901,7 @@
           <a:p>
             <a:fld id="{36125577-04C1-4DFE-9495-826892B20392}" type="datetimeFigureOut">
               <a:rPr lang="en-US" smtClean="0"/>
-              <a:t>8/12/2026</a:t>
+              <a:t>8/19/2026</a:t>
             </a:fld>
             <a:endParaRPr lang="en-US"/>
           </a:p>
@@ -2803,7 +3212,7 @@
           <a:p>
             <a:fld id="{36125577-04C1-4DFE-9495-826892B20392}" type="datetimeFigureOut">
               <a:rPr lang="en-US" smtClean="0"/>
-              <a:t>8/12/2026</a:t>
+              <a:t>8/19/2026</a:t>
             </a:fld>
             <a:endParaRPr lang="en-US"/>
           </a:p>
@@ -3091,7 +3500,7 @@
           <a:p>
             <a:fld id="{36125577-04C1-4DFE-9495-826892B20392}" type="datetimeFigureOut">
               <a:rPr lang="en-US" smtClean="0"/>
-              <a:t>8/12/2026</a:t>
+              <a:t>8/19/2026</a:t>
             </a:fld>
             <a:endParaRPr lang="en-US"/>
           </a:p>
@@ -3332,7 +3741,7 @@
           <a:p>
             <a:fld id="{36125577-04C1-4DFE-9495-826892B20392}" type="datetimeFigureOut">
               <a:rPr lang="en-US" smtClean="0"/>
-              <a:t>8/12/2026</a:t>
+              <a:t>8/19/2026</a:t>
             </a:fld>
             <a:endParaRPr lang="en-US"/>
           </a:p>
@@ -4019,339 +4428,6 @@
   <p:cSld>
     <p:spTree>
       <p:nvGrpSpPr>
-        <p:cNvPr id="1" name=""/>
-        <p:cNvGrpSpPr/>
-        <p:nvPr/>
-      </p:nvGrpSpPr>
-      <p:grpSpPr>
-        <a:xfrm>
-          <a:off x="0" y="0"/>
-          <a:ext cx="0" cy="0"/>
-          <a:chOff x="0" y="0"/>
-          <a:chExt cx="0" cy="0"/>
-        </a:xfrm>
-      </p:grpSpPr>
-      <p:sp>
-        <p:nvSpPr>
-          <p:cNvPr id="2" name="Title 1">
-            <a:extLst>
-              <a:ext uri="{FF2B5EF4-FFF2-40B4-BE49-F238E27FC236}">
-                <a16:creationId xmlns:a16="http://schemas.microsoft.com/office/drawing/2014/main" id="{828303BE-97E1-3299-8F4D-CD015365AE6C}"/>
-              </a:ext>
-            </a:extLst>
-          </p:cNvPr>
-          <p:cNvSpPr>
-            <a:spLocks noGrp="1"/>
-          </p:cNvSpPr>
-          <p:nvPr>
-            <p:ph type="title"/>
-          </p:nvPr>
-        </p:nvSpPr>
-        <p:spPr/>
-        <p:txBody>
-          <a:bodyPr/>
-          <a:lstStyle/>
-          <a:p>
-            <a:pPr algn="ctr"/>
-            <a:r>
-              <a:rPr lang="en-US" dirty="0"/>
-              <a:t>Comparison of USGS Bay and Channel Transects</a:t>
-            </a:r>
-          </a:p>
-        </p:txBody>
-      </p:sp>
-      <p:pic>
-        <p:nvPicPr>
-          <p:cNvPr id="5" name="Content Placeholder 4">
-            <a:extLst>
-              <a:ext uri="{FF2B5EF4-FFF2-40B4-BE49-F238E27FC236}">
-                <a16:creationId xmlns:a16="http://schemas.microsoft.com/office/drawing/2014/main" id="{4B28ED72-DD4F-8C1D-A526-86EE4E1B9A61}"/>
-              </a:ext>
-            </a:extLst>
-          </p:cNvPr>
-          <p:cNvPicPr>
-            <a:picLocks noGrp="1" noChangeAspect="1"/>
-          </p:cNvPicPr>
-          <p:nvPr>
-            <p:ph idx="1"/>
-          </p:nvPr>
-        </p:nvPicPr>
-        <p:blipFill>
-          <a:blip r:embed="rId2"/>
-          <a:stretch>
-            <a:fillRect/>
-          </a:stretch>
-        </p:blipFill>
-        <p:spPr>
-          <a:xfrm>
-            <a:off x="2129392" y="1690688"/>
-            <a:ext cx="8311564" cy="4652762"/>
-          </a:xfrm>
-          <a:prstGeom prst="rect">
-            <a:avLst/>
-          </a:prstGeom>
-        </p:spPr>
-      </p:pic>
-    </p:spTree>
-    <p:extLst>
-      <p:ext uri="{BB962C8B-B14F-4D97-AF65-F5344CB8AC3E}">
-        <p14:creationId xmlns:p14="http://schemas.microsoft.com/office/powerpoint/2010/main" val="486497429"/>
-      </p:ext>
-    </p:extLst>
-  </p:cSld>
-  <p:clrMapOvr>
-    <a:masterClrMapping/>
-  </p:clrMapOvr>
-</p:sld>
-</file>
-
-<file path=ppt/slides/slide12.xml><?xml version="1.0" encoding="utf-8"?>
-<p:sld xmlns:a="http://schemas.openxmlformats.org/drawingml/2006/main" xmlns:r="http://schemas.openxmlformats.org/officeDocument/2006/relationships" xmlns:p="http://schemas.openxmlformats.org/presentationml/2006/main">
-  <p:cSld>
-    <p:spTree>
-      <p:nvGrpSpPr>
-        <p:cNvPr id="1" name=""/>
-        <p:cNvGrpSpPr/>
-        <p:nvPr/>
-      </p:nvGrpSpPr>
-      <p:grpSpPr>
-        <a:xfrm>
-          <a:off x="0" y="0"/>
-          <a:ext cx="0" cy="0"/>
-          <a:chOff x="0" y="0"/>
-          <a:chExt cx="0" cy="0"/>
-        </a:xfrm>
-      </p:grpSpPr>
-      <p:sp>
-        <p:nvSpPr>
-          <p:cNvPr id="2" name="Title 1">
-            <a:extLst>
-              <a:ext uri="{FF2B5EF4-FFF2-40B4-BE49-F238E27FC236}">
-                <a16:creationId xmlns:a16="http://schemas.microsoft.com/office/drawing/2014/main" id="{43389EDE-6E73-950C-728E-C9304FEE2ADF}"/>
-              </a:ext>
-            </a:extLst>
-          </p:cNvPr>
-          <p:cNvSpPr>
-            <a:spLocks noGrp="1"/>
-          </p:cNvSpPr>
-          <p:nvPr>
-            <p:ph type="title"/>
-          </p:nvPr>
-        </p:nvSpPr>
-        <p:spPr/>
-        <p:txBody>
-          <a:bodyPr/>
-          <a:lstStyle/>
-          <a:p>
-            <a:r>
-              <a:rPr lang="en-US" dirty="0"/>
-              <a:t>RQ #3 Wind Versus Sediment Deposition</a:t>
-            </a:r>
-          </a:p>
-        </p:txBody>
-      </p:sp>
-      <p:pic>
-        <p:nvPicPr>
-          <p:cNvPr id="13" name="Content Placeholder 12">
-            <a:extLst>
-              <a:ext uri="{FF2B5EF4-FFF2-40B4-BE49-F238E27FC236}">
-                <a16:creationId xmlns:a16="http://schemas.microsoft.com/office/drawing/2014/main" id="{4C7567C2-EA05-EA38-EF7F-4F82C1F9E5D1}"/>
-              </a:ext>
-            </a:extLst>
-          </p:cNvPr>
-          <p:cNvPicPr>
-            <a:picLocks noGrp="1" noChangeAspect="1"/>
-          </p:cNvPicPr>
-          <p:nvPr>
-            <p:ph idx="1"/>
-          </p:nvPr>
-        </p:nvPicPr>
-        <p:blipFill>
-          <a:blip r:embed="rId2"/>
-          <a:stretch>
-            <a:fillRect/>
-          </a:stretch>
-        </p:blipFill>
-        <p:spPr>
-          <a:xfrm>
-            <a:off x="5547889" y="1451443"/>
-            <a:ext cx="6502639" cy="4099152"/>
-          </a:xfrm>
-          <a:prstGeom prst="rect">
-            <a:avLst/>
-          </a:prstGeom>
-        </p:spPr>
-      </p:pic>
-      <p:pic>
-        <p:nvPicPr>
-          <p:cNvPr id="17" name="Picture 16">
-            <a:extLst>
-              <a:ext uri="{FF2B5EF4-FFF2-40B4-BE49-F238E27FC236}">
-                <a16:creationId xmlns:a16="http://schemas.microsoft.com/office/drawing/2014/main" id="{726B37FA-9DE5-3D3E-5230-48ABA774FB4D}"/>
-              </a:ext>
-            </a:extLst>
-          </p:cNvPr>
-          <p:cNvPicPr>
-            <a:picLocks noChangeAspect="1"/>
-          </p:cNvPicPr>
-          <p:nvPr/>
-        </p:nvPicPr>
-        <p:blipFill>
-          <a:blip r:embed="rId3"/>
-          <a:stretch>
-            <a:fillRect/>
-          </a:stretch>
-        </p:blipFill>
-        <p:spPr>
-          <a:xfrm>
-            <a:off x="0" y="1739864"/>
-            <a:ext cx="5610104" cy="3522310"/>
-          </a:xfrm>
-          <a:prstGeom prst="rect">
-            <a:avLst/>
-          </a:prstGeom>
-        </p:spPr>
-      </p:pic>
-    </p:spTree>
-    <p:extLst>
-      <p:ext uri="{BB962C8B-B14F-4D97-AF65-F5344CB8AC3E}">
-        <p14:creationId xmlns:p14="http://schemas.microsoft.com/office/powerpoint/2010/main" val="1052528304"/>
-      </p:ext>
-    </p:extLst>
-  </p:cSld>
-  <p:clrMapOvr>
-    <a:masterClrMapping/>
-  </p:clrMapOvr>
-</p:sld>
-</file>
-
-<file path=ppt/slides/slide13.xml><?xml version="1.0" encoding="utf-8"?>
-<p:sld xmlns:a="http://schemas.openxmlformats.org/drawingml/2006/main" xmlns:r="http://schemas.openxmlformats.org/officeDocument/2006/relationships" xmlns:p="http://schemas.openxmlformats.org/presentationml/2006/main">
-  <p:cSld>
-    <p:spTree>
-      <p:nvGrpSpPr>
-        <p:cNvPr id="1" name=""/>
-        <p:cNvGrpSpPr/>
-        <p:nvPr/>
-      </p:nvGrpSpPr>
-      <p:grpSpPr>
-        <a:xfrm>
-          <a:off x="0" y="0"/>
-          <a:ext cx="0" cy="0"/>
-          <a:chOff x="0" y="0"/>
-          <a:chExt cx="0" cy="0"/>
-        </a:xfrm>
-      </p:grpSpPr>
-      <p:sp>
-        <p:nvSpPr>
-          <p:cNvPr id="2" name="Title 1">
-            <a:extLst>
-              <a:ext uri="{FF2B5EF4-FFF2-40B4-BE49-F238E27FC236}">
-                <a16:creationId xmlns:a16="http://schemas.microsoft.com/office/drawing/2014/main" id="{09088601-E465-1B77-5DFB-E21827DA476A}"/>
-              </a:ext>
-            </a:extLst>
-          </p:cNvPr>
-          <p:cNvSpPr>
-            <a:spLocks noGrp="1"/>
-          </p:cNvSpPr>
-          <p:nvPr>
-            <p:ph type="title"/>
-          </p:nvPr>
-        </p:nvSpPr>
-        <p:spPr/>
-        <p:txBody>
-          <a:bodyPr>
-            <a:normAutofit/>
-          </a:bodyPr>
-          <a:lstStyle/>
-          <a:p>
-            <a:r>
-              <a:rPr lang="en-US" dirty="0"/>
-              <a:t>RQ# 3: “Local” Slope versus Sediment Deposition</a:t>
-            </a:r>
-          </a:p>
-        </p:txBody>
-      </p:sp>
-      <p:pic>
-        <p:nvPicPr>
-          <p:cNvPr id="7" name="Picture 6">
-            <a:extLst>
-              <a:ext uri="{FF2B5EF4-FFF2-40B4-BE49-F238E27FC236}">
-                <a16:creationId xmlns:a16="http://schemas.microsoft.com/office/drawing/2014/main" id="{20941BF4-9E9F-5C22-FA4A-AD297C6EAEB7}"/>
-              </a:ext>
-            </a:extLst>
-          </p:cNvPr>
-          <p:cNvPicPr>
-            <a:picLocks noChangeAspect="1"/>
-          </p:cNvPicPr>
-          <p:nvPr/>
-        </p:nvPicPr>
-        <p:blipFill>
-          <a:blip r:embed="rId2"/>
-          <a:stretch>
-            <a:fillRect/>
-          </a:stretch>
-        </p:blipFill>
-        <p:spPr>
-          <a:xfrm>
-            <a:off x="107569" y="1901951"/>
-            <a:ext cx="6009457" cy="3632957"/>
-          </a:xfrm>
-          <a:prstGeom prst="rect">
-            <a:avLst/>
-          </a:prstGeom>
-        </p:spPr>
-      </p:pic>
-      <p:pic>
-        <p:nvPicPr>
-          <p:cNvPr id="11" name="Content Placeholder 10">
-            <a:extLst>
-              <a:ext uri="{FF2B5EF4-FFF2-40B4-BE49-F238E27FC236}">
-                <a16:creationId xmlns:a16="http://schemas.microsoft.com/office/drawing/2014/main" id="{DEFE12E2-1EED-6518-94C9-AB0F5F088D46}"/>
-              </a:ext>
-            </a:extLst>
-          </p:cNvPr>
-          <p:cNvPicPr>
-            <a:picLocks noGrp="1" noChangeAspect="1"/>
-          </p:cNvPicPr>
-          <p:nvPr>
-            <p:ph idx="1"/>
-          </p:nvPr>
-        </p:nvPicPr>
-        <p:blipFill>
-          <a:blip r:embed="rId3"/>
-          <a:stretch>
-            <a:fillRect/>
-          </a:stretch>
-        </p:blipFill>
-        <p:spPr>
-          <a:xfrm>
-            <a:off x="6421890" y="1901952"/>
-            <a:ext cx="5662541" cy="3632957"/>
-          </a:xfrm>
-          <a:prstGeom prst="rect">
-            <a:avLst/>
-          </a:prstGeom>
-        </p:spPr>
-      </p:pic>
-    </p:spTree>
-    <p:extLst>
-      <p:ext uri="{BB962C8B-B14F-4D97-AF65-F5344CB8AC3E}">
-        <p14:creationId xmlns:p14="http://schemas.microsoft.com/office/powerpoint/2010/main" val="200294253"/>
-      </p:ext>
-    </p:extLst>
-  </p:cSld>
-  <p:clrMapOvr>
-    <a:masterClrMapping/>
-  </p:clrMapOvr>
-</p:sld>
-</file>
-
-<file path=ppt/slides/slide14.xml><?xml version="1.0" encoding="utf-8"?>
-<p:sld xmlns:a="http://schemas.openxmlformats.org/drawingml/2006/main" xmlns:r="http://schemas.openxmlformats.org/officeDocument/2006/relationships" xmlns:p="http://schemas.openxmlformats.org/presentationml/2006/main">
-  <p:cSld>
-    <p:spTree>
-      <p:nvGrpSpPr>
         <p:cNvPr id="1" name="">
           <a:extLst>
             <a:ext uri="{FF2B5EF4-FFF2-40B4-BE49-F238E27FC236}">
@@ -4569,182 +4645,7 @@
 </p:sld>
 </file>
 
-<file path=ppt/slides/slide2.xml><?xml version="1.0" encoding="utf-8"?>
-<p:sld xmlns:a="http://schemas.openxmlformats.org/drawingml/2006/main" xmlns:r="http://schemas.openxmlformats.org/officeDocument/2006/relationships" xmlns:p="http://schemas.openxmlformats.org/presentationml/2006/main">
-  <p:cSld>
-    <p:spTree>
-      <p:nvGrpSpPr>
-        <p:cNvPr id="1" name=""/>
-        <p:cNvGrpSpPr/>
-        <p:nvPr/>
-      </p:nvGrpSpPr>
-      <p:grpSpPr>
-        <a:xfrm>
-          <a:off x="0" y="0"/>
-          <a:ext cx="0" cy="0"/>
-          <a:chOff x="0" y="0"/>
-          <a:chExt cx="0" cy="0"/>
-        </a:xfrm>
-      </p:grpSpPr>
-      <p:sp>
-        <p:nvSpPr>
-          <p:cNvPr id="2" name="Title 1">
-            <a:extLst>
-              <a:ext uri="{FF2B5EF4-FFF2-40B4-BE49-F238E27FC236}">
-                <a16:creationId xmlns:a16="http://schemas.microsoft.com/office/drawing/2014/main" id="{88A78E77-2410-48D8-E204-60A734D8DC23}"/>
-              </a:ext>
-            </a:extLst>
-          </p:cNvPr>
-          <p:cNvSpPr>
-            <a:spLocks noGrp="1"/>
-          </p:cNvSpPr>
-          <p:nvPr>
-            <p:ph type="title"/>
-          </p:nvPr>
-        </p:nvSpPr>
-        <p:spPr/>
-        <p:txBody>
-          <a:bodyPr/>
-          <a:lstStyle/>
-          <a:p>
-            <a:r>
-              <a:rPr lang="en-US" dirty="0"/>
-              <a:t>Summary-Sediment and Abiotic Variables</a:t>
-            </a:r>
-          </a:p>
-        </p:txBody>
-      </p:sp>
-      <p:sp>
-        <p:nvSpPr>
-          <p:cNvPr id="3" name="Content Placeholder 2">
-            <a:extLst>
-              <a:ext uri="{FF2B5EF4-FFF2-40B4-BE49-F238E27FC236}">
-                <a16:creationId xmlns:a16="http://schemas.microsoft.com/office/drawing/2014/main" id="{22F931F0-4409-18B6-3C54-02E0CF904623}"/>
-              </a:ext>
-            </a:extLst>
-          </p:cNvPr>
-          <p:cNvSpPr>
-            <a:spLocks noGrp="1"/>
-          </p:cNvSpPr>
-          <p:nvPr>
-            <p:ph idx="1"/>
-          </p:nvPr>
-        </p:nvSpPr>
-        <p:spPr/>
-        <p:txBody>
-          <a:bodyPr>
-            <a:normAutofit fontScale="92500" lnSpcReduction="10000"/>
-          </a:bodyPr>
-          <a:lstStyle/>
-          <a:p>
-            <a:pPr marL="0" indent="0">
-              <a:buNone/>
-            </a:pPr>
-            <a:r>
-              <a:rPr lang="en-US" b="1" dirty="0"/>
-              <a:t>Merged USGS and Thesis Sediment Deposition data into one </a:t>
-            </a:r>
-            <a:r>
-              <a:rPr lang="en-US" b="1" dirty="0" err="1"/>
-              <a:t>dataframe</a:t>
-            </a:r>
-            <a:r>
-              <a:rPr lang="en-US" b="1" dirty="0"/>
-              <a:t>! </a:t>
-            </a:r>
-          </a:p>
-          <a:p>
-            <a:pPr marL="0" indent="0">
-              <a:buNone/>
-            </a:pPr>
-            <a:r>
-              <a:rPr lang="en-US" dirty="0"/>
-              <a:t>Thesis includes additional variables:</a:t>
-            </a:r>
-          </a:p>
-          <a:p>
-            <a:pPr lvl="1"/>
-            <a:r>
-              <a:rPr lang="en-US" dirty="0"/>
-              <a:t>“local slope”</a:t>
-            </a:r>
-          </a:p>
-          <a:p>
-            <a:pPr lvl="2"/>
-            <a:r>
-              <a:rPr lang="en-US" dirty="0"/>
-              <a:t>Extrapolated from marsh edge horizontal profile (June 2025) to the most recent RTK surveys of the transect (Nov. 2025-March 2025)</a:t>
-            </a:r>
-          </a:p>
-          <a:p>
-            <a:pPr lvl="1"/>
-            <a:r>
-              <a:rPr lang="en-US" dirty="0"/>
-              <a:t>mean wind speed</a:t>
-            </a:r>
-          </a:p>
-          <a:p>
-            <a:pPr lvl="2"/>
-            <a:r>
-              <a:rPr lang="en-US" dirty="0"/>
-              <a:t>Calculated per site, spanning time of Day filter was placed-Day filter was collected</a:t>
-            </a:r>
-          </a:p>
-          <a:p>
-            <a:pPr marL="0" indent="0">
-              <a:buNone/>
-            </a:pPr>
-            <a:r>
-              <a:rPr lang="en-US" dirty="0"/>
-              <a:t>USGS includes additional variables and elements: </a:t>
-            </a:r>
-          </a:p>
-          <a:p>
-            <a:pPr lvl="1"/>
-            <a:r>
-              <a:rPr lang="en-US" dirty="0"/>
-              <a:t>Bay (Transects A, B) and Channel (Transects C, D) incorporated in data frames</a:t>
-            </a:r>
-          </a:p>
-          <a:p>
-            <a:pPr lvl="1"/>
-            <a:r>
-              <a:rPr lang="en-US" dirty="0"/>
-              <a:t>Calculated z* to pair with thesis measurements </a:t>
-            </a:r>
-          </a:p>
-          <a:p>
-            <a:pPr lvl="2"/>
-            <a:r>
-              <a:rPr lang="en-US" dirty="0"/>
-              <a:t>Used same BCDC stations as Thesis for standardization </a:t>
-            </a:r>
-          </a:p>
-          <a:p>
-            <a:pPr marL="914400" lvl="2" indent="0">
-              <a:buNone/>
-            </a:pPr>
-            <a:endParaRPr lang="en-US" dirty="0"/>
-          </a:p>
-          <a:p>
-            <a:endParaRPr lang="en-US" dirty="0"/>
-          </a:p>
-        </p:txBody>
-      </p:sp>
-    </p:spTree>
-    <p:extLst>
-      <p:ext uri="{BB962C8B-B14F-4D97-AF65-F5344CB8AC3E}">
-        <p14:creationId xmlns:p14="http://schemas.microsoft.com/office/powerpoint/2010/main" val="1137524809"/>
-      </p:ext>
-    </p:extLst>
-  </p:cSld>
-  <p:clrMapOvr>
-    <a:masterClrMapping/>
-  </p:clrMapOvr>
-</p:sld>
-</file>
-
-<file path=ppt/slides/slide3.xml><?xml version="1.0" encoding="utf-8"?>
+<file path=ppt/slides/slide12.xml><?xml version="1.0" encoding="utf-8"?>
 <p:sld xmlns:a="http://schemas.openxmlformats.org/drawingml/2006/main" xmlns:r="http://schemas.openxmlformats.org/officeDocument/2006/relationships" xmlns:p="http://schemas.openxmlformats.org/presentationml/2006/main">
   <p:cSld>
     <p:spTree>
@@ -4790,7 +4691,7 @@
           <a:p>
             <a:r>
               <a:rPr lang="en-US" dirty="0"/>
-              <a:t>Summary-Vegetation</a:t>
+              <a:t>Appendices (Descriptive Data): Vegetation</a:t>
             </a:r>
           </a:p>
         </p:txBody>
@@ -4919,7 +4820,7 @@
     </p:spTree>
     <p:extLst>
       <p:ext uri="{BB962C8B-B14F-4D97-AF65-F5344CB8AC3E}">
-        <p14:creationId xmlns:p14="http://schemas.microsoft.com/office/powerpoint/2010/main" val="149973421"/>
+        <p14:creationId xmlns:p14="http://schemas.microsoft.com/office/powerpoint/2010/main" val="2465619183"/>
       </p:ext>
     </p:extLst>
   </p:cSld>
@@ -4929,7 +4830,1249 @@
 </p:sld>
 </file>
 
-<file path=ppt/slides/slide4.xml><?xml version="1.0" encoding="utf-8"?>
+<file path=ppt/slides/slide13.xml><?xml version="1.0" encoding="utf-8"?>
+<p:sld xmlns:a="http://schemas.openxmlformats.org/drawingml/2006/main" xmlns:r="http://schemas.openxmlformats.org/officeDocument/2006/relationships" xmlns:p="http://schemas.openxmlformats.org/presentationml/2006/main">
+  <p:cSld>
+    <p:spTree>
+      <p:nvGrpSpPr>
+        <p:cNvPr id="1" name="">
+          <a:extLst>
+            <a:ext uri="{FF2B5EF4-FFF2-40B4-BE49-F238E27FC236}">
+              <a16:creationId xmlns:a16="http://schemas.microsoft.com/office/drawing/2014/main" id="{A2CCAAD6-61C1-2300-2E1A-535C7799802C}"/>
+            </a:ext>
+          </a:extLst>
+        </p:cNvPr>
+        <p:cNvGrpSpPr/>
+        <p:nvPr/>
+      </p:nvGrpSpPr>
+      <p:grpSpPr>
+        <a:xfrm>
+          <a:off x="0" y="0"/>
+          <a:ext cx="0" cy="0"/>
+          <a:chOff x="0" y="0"/>
+          <a:chExt cx="0" cy="0"/>
+        </a:xfrm>
+      </p:grpSpPr>
+      <p:sp>
+        <p:nvSpPr>
+          <p:cNvPr id="5" name="Title 4">
+            <a:extLst>
+              <a:ext uri="{FF2B5EF4-FFF2-40B4-BE49-F238E27FC236}">
+                <a16:creationId xmlns:a16="http://schemas.microsoft.com/office/drawing/2014/main" id="{53439E7B-1209-C36E-C8AA-60B925D418AD}"/>
+              </a:ext>
+            </a:extLst>
+          </p:cNvPr>
+          <p:cNvSpPr>
+            <a:spLocks noGrp="1"/>
+          </p:cNvSpPr>
+          <p:nvPr>
+            <p:ph type="title"/>
+          </p:nvPr>
+        </p:nvSpPr>
+        <p:spPr/>
+        <p:txBody>
+          <a:bodyPr>
+            <a:normAutofit/>
+          </a:bodyPr>
+          <a:lstStyle/>
+          <a:p>
+            <a:r>
+              <a:rPr lang="en-US" sz="4000" dirty="0"/>
+              <a:t>Appendices (Descriptive Data): Wind Direction</a:t>
+            </a:r>
+          </a:p>
+        </p:txBody>
+      </p:sp>
+      <p:pic>
+        <p:nvPicPr>
+          <p:cNvPr id="6" name="Content Placeholder 5">
+            <a:extLst>
+              <a:ext uri="{FF2B5EF4-FFF2-40B4-BE49-F238E27FC236}">
+                <a16:creationId xmlns:a16="http://schemas.microsoft.com/office/drawing/2014/main" id="{2DD3CF05-1033-5F10-ED03-2651C114977F}"/>
+              </a:ext>
+            </a:extLst>
+          </p:cNvPr>
+          <p:cNvPicPr>
+            <a:picLocks noGrp="1" noChangeAspect="1"/>
+          </p:cNvPicPr>
+          <p:nvPr>
+            <p:ph sz="half" idx="1"/>
+          </p:nvPr>
+        </p:nvPicPr>
+        <p:blipFill>
+          <a:blip r:embed="rId2"/>
+          <a:stretch>
+            <a:fillRect/>
+          </a:stretch>
+        </p:blipFill>
+        <p:spPr>
+          <a:xfrm>
+            <a:off x="2886074" y="1397001"/>
+            <a:ext cx="6619875" cy="5295899"/>
+          </a:xfrm>
+          <a:prstGeom prst="rect">
+            <a:avLst/>
+          </a:prstGeom>
+        </p:spPr>
+      </p:pic>
+    </p:spTree>
+    <p:extLst>
+      <p:ext uri="{BB962C8B-B14F-4D97-AF65-F5344CB8AC3E}">
+        <p14:creationId xmlns:p14="http://schemas.microsoft.com/office/powerpoint/2010/main" val="1423438856"/>
+      </p:ext>
+    </p:extLst>
+  </p:cSld>
+  <p:clrMapOvr>
+    <a:masterClrMapping/>
+  </p:clrMapOvr>
+</p:sld>
+</file>
+
+<file path=ppt/slides/slide14.xml><?xml version="1.0" encoding="utf-8"?>
+<p:sld xmlns:a="http://schemas.openxmlformats.org/drawingml/2006/main" xmlns:r="http://schemas.openxmlformats.org/officeDocument/2006/relationships" xmlns:p="http://schemas.openxmlformats.org/presentationml/2006/main">
+  <p:cSld>
+    <p:spTree>
+      <p:nvGrpSpPr>
+        <p:cNvPr id="1" name="">
+          <a:extLst>
+            <a:ext uri="{FF2B5EF4-FFF2-40B4-BE49-F238E27FC236}">
+              <a16:creationId xmlns:a16="http://schemas.microsoft.com/office/drawing/2014/main" id="{38662EA8-72DB-29C9-70AD-277FA7963540}"/>
+            </a:ext>
+          </a:extLst>
+        </p:cNvPr>
+        <p:cNvGrpSpPr/>
+        <p:nvPr/>
+      </p:nvGrpSpPr>
+      <p:grpSpPr>
+        <a:xfrm>
+          <a:off x="0" y="0"/>
+          <a:ext cx="0" cy="0"/>
+          <a:chOff x="0" y="0"/>
+          <a:chExt cx="0" cy="0"/>
+        </a:xfrm>
+      </p:grpSpPr>
+      <p:sp>
+        <p:nvSpPr>
+          <p:cNvPr id="5" name="Title 4">
+            <a:extLst>
+              <a:ext uri="{FF2B5EF4-FFF2-40B4-BE49-F238E27FC236}">
+                <a16:creationId xmlns:a16="http://schemas.microsoft.com/office/drawing/2014/main" id="{1AC1C78C-F114-9F03-CABB-D1F643B2F9CF}"/>
+              </a:ext>
+            </a:extLst>
+          </p:cNvPr>
+          <p:cNvSpPr>
+            <a:spLocks noGrp="1"/>
+          </p:cNvSpPr>
+          <p:nvPr>
+            <p:ph type="title"/>
+          </p:nvPr>
+        </p:nvSpPr>
+        <p:spPr/>
+        <p:txBody>
+          <a:bodyPr>
+            <a:normAutofit/>
+          </a:bodyPr>
+          <a:lstStyle/>
+          <a:p>
+            <a:r>
+              <a:rPr lang="en-US" sz="4000" dirty="0"/>
+              <a:t>Appendices (Descriptive Data): Wind Direction</a:t>
+            </a:r>
+          </a:p>
+        </p:txBody>
+      </p:sp>
+      <p:pic>
+        <p:nvPicPr>
+          <p:cNvPr id="8" name="Content Placeholder 7">
+            <a:extLst>
+              <a:ext uri="{FF2B5EF4-FFF2-40B4-BE49-F238E27FC236}">
+                <a16:creationId xmlns:a16="http://schemas.microsoft.com/office/drawing/2014/main" id="{C92C93C1-B35A-EFBF-A16F-4E639ADB4BF1}"/>
+              </a:ext>
+            </a:extLst>
+          </p:cNvPr>
+          <p:cNvPicPr>
+            <a:picLocks noGrp="1" noChangeAspect="1"/>
+          </p:cNvPicPr>
+          <p:nvPr>
+            <p:ph sz="half" idx="1"/>
+          </p:nvPr>
+        </p:nvPicPr>
+        <p:blipFill>
+          <a:blip r:embed="rId2">
+            <a:extLst>
+              <a:ext uri="{28A0092B-C50C-407E-A947-70E740481C1C}">
+                <a14:useLocalDpi xmlns:a14="http://schemas.microsoft.com/office/drawing/2010/main" val="0"/>
+              </a:ext>
+            </a:extLst>
+          </a:blip>
+          <a:stretch>
+            <a:fillRect/>
+          </a:stretch>
+        </p:blipFill>
+        <p:spPr>
+          <a:xfrm>
+            <a:off x="2600325" y="1351438"/>
+            <a:ext cx="6581776" cy="5265420"/>
+          </a:xfrm>
+          <a:prstGeom prst="rect">
+            <a:avLst/>
+          </a:prstGeom>
+        </p:spPr>
+      </p:pic>
+    </p:spTree>
+    <p:extLst>
+      <p:ext uri="{BB962C8B-B14F-4D97-AF65-F5344CB8AC3E}">
+        <p14:creationId xmlns:p14="http://schemas.microsoft.com/office/powerpoint/2010/main" val="60502188"/>
+      </p:ext>
+    </p:extLst>
+  </p:cSld>
+  <p:clrMapOvr>
+    <a:masterClrMapping/>
+  </p:clrMapOvr>
+</p:sld>
+</file>
+
+<file path=ppt/slides/slide15.xml><?xml version="1.0" encoding="utf-8"?>
+<p:sld xmlns:a="http://schemas.openxmlformats.org/drawingml/2006/main" xmlns:r="http://schemas.openxmlformats.org/officeDocument/2006/relationships" xmlns:p="http://schemas.openxmlformats.org/presentationml/2006/main">
+  <p:cSld>
+    <p:spTree>
+      <p:nvGrpSpPr>
+        <p:cNvPr id="1" name="">
+          <a:extLst>
+            <a:ext uri="{FF2B5EF4-FFF2-40B4-BE49-F238E27FC236}">
+              <a16:creationId xmlns:a16="http://schemas.microsoft.com/office/drawing/2014/main" id="{9AEDFE0F-2DDF-9C48-E67B-1E4CD0B7C70D}"/>
+            </a:ext>
+          </a:extLst>
+        </p:cNvPr>
+        <p:cNvGrpSpPr/>
+        <p:nvPr/>
+      </p:nvGrpSpPr>
+      <p:grpSpPr>
+        <a:xfrm>
+          <a:off x="0" y="0"/>
+          <a:ext cx="0" cy="0"/>
+          <a:chOff x="0" y="0"/>
+          <a:chExt cx="0" cy="0"/>
+        </a:xfrm>
+      </p:grpSpPr>
+      <p:sp>
+        <p:nvSpPr>
+          <p:cNvPr id="5" name="Title 4">
+            <a:extLst>
+              <a:ext uri="{FF2B5EF4-FFF2-40B4-BE49-F238E27FC236}">
+                <a16:creationId xmlns:a16="http://schemas.microsoft.com/office/drawing/2014/main" id="{A33E62B1-48AB-68EA-CB4F-5AB9099C19C1}"/>
+              </a:ext>
+            </a:extLst>
+          </p:cNvPr>
+          <p:cNvSpPr>
+            <a:spLocks noGrp="1"/>
+          </p:cNvSpPr>
+          <p:nvPr>
+            <p:ph type="title"/>
+          </p:nvPr>
+        </p:nvSpPr>
+        <p:spPr>
+          <a:xfrm>
+            <a:off x="733425" y="0"/>
+            <a:ext cx="10515600" cy="1325563"/>
+          </a:xfrm>
+        </p:spPr>
+        <p:txBody>
+          <a:bodyPr>
+            <a:normAutofit/>
+          </a:bodyPr>
+          <a:lstStyle/>
+          <a:p>
+            <a:r>
+              <a:rPr lang="en-US" sz="4000" dirty="0"/>
+              <a:t>Appendices (Descriptive Data): Wind Direction</a:t>
+            </a:r>
+          </a:p>
+        </p:txBody>
+      </p:sp>
+      <p:pic>
+        <p:nvPicPr>
+          <p:cNvPr id="9" name="Content Placeholder 8">
+            <a:extLst>
+              <a:ext uri="{FF2B5EF4-FFF2-40B4-BE49-F238E27FC236}">
+                <a16:creationId xmlns:a16="http://schemas.microsoft.com/office/drawing/2014/main" id="{A8941919-1DF5-6728-17D0-5F1E0900DDF2}"/>
+              </a:ext>
+            </a:extLst>
+          </p:cNvPr>
+          <p:cNvPicPr>
+            <a:picLocks noGrp="1" noChangeAspect="1"/>
+          </p:cNvPicPr>
+          <p:nvPr>
+            <p:ph sz="half" idx="1"/>
+          </p:nvPr>
+        </p:nvPicPr>
+        <p:blipFill>
+          <a:blip r:embed="rId2">
+            <a:extLst>
+              <a:ext uri="{28A0092B-C50C-407E-A947-70E740481C1C}">
+                <a14:useLocalDpi xmlns:a14="http://schemas.microsoft.com/office/drawing/2010/main" val="0"/>
+              </a:ext>
+            </a:extLst>
+          </a:blip>
+          <a:stretch>
+            <a:fillRect/>
+          </a:stretch>
+        </p:blipFill>
+        <p:spPr>
+          <a:xfrm>
+            <a:off x="6629400" y="1767921"/>
+            <a:ext cx="4400550" cy="4400550"/>
+          </a:xfrm>
+          <a:prstGeom prst="rect">
+            <a:avLst/>
+          </a:prstGeom>
+        </p:spPr>
+      </p:pic>
+      <p:sp>
+        <p:nvSpPr>
+          <p:cNvPr id="14" name="TextBox 13">
+            <a:extLst>
+              <a:ext uri="{FF2B5EF4-FFF2-40B4-BE49-F238E27FC236}">
+                <a16:creationId xmlns:a16="http://schemas.microsoft.com/office/drawing/2014/main" id="{A6364580-F88B-1990-D4B7-7AAC60649506}"/>
+              </a:ext>
+            </a:extLst>
+          </p:cNvPr>
+          <p:cNvSpPr txBox="1"/>
+          <p:nvPr/>
+        </p:nvSpPr>
+        <p:spPr>
+          <a:xfrm>
+            <a:off x="4495800" y="1325563"/>
+            <a:ext cx="2990850" cy="369332"/>
+          </a:xfrm>
+          <a:prstGeom prst="rect">
+            <a:avLst/>
+          </a:prstGeom>
+          <a:noFill/>
+        </p:spPr>
+        <p:txBody>
+          <a:bodyPr wrap="square" rtlCol="0">
+            <a:spAutoFit/>
+          </a:bodyPr>
+          <a:lstStyle/>
+          <a:p>
+            <a:pPr algn="ctr"/>
+            <a:r>
+              <a:rPr lang="en-US" b="1" dirty="0"/>
+              <a:t>July-October 2025</a:t>
+            </a:r>
+          </a:p>
+        </p:txBody>
+      </p:sp>
+      <p:pic>
+        <p:nvPicPr>
+          <p:cNvPr id="18" name="Picture 17">
+            <a:extLst>
+              <a:ext uri="{FF2B5EF4-FFF2-40B4-BE49-F238E27FC236}">
+                <a16:creationId xmlns:a16="http://schemas.microsoft.com/office/drawing/2014/main" id="{EAB29286-2DDD-2F18-5B92-1628567F20B6}"/>
+              </a:ext>
+            </a:extLst>
+          </p:cNvPr>
+          <p:cNvPicPr>
+            <a:picLocks noChangeAspect="1"/>
+          </p:cNvPicPr>
+          <p:nvPr/>
+        </p:nvPicPr>
+        <p:blipFill>
+          <a:blip r:embed="rId3">
+            <a:extLst>
+              <a:ext uri="{28A0092B-C50C-407E-A947-70E740481C1C}">
+                <a14:useLocalDpi xmlns:a14="http://schemas.microsoft.com/office/drawing/2010/main" val="0"/>
+              </a:ext>
+            </a:extLst>
+          </a:blip>
+          <a:stretch>
+            <a:fillRect/>
+          </a:stretch>
+        </p:blipFill>
+        <p:spPr>
+          <a:xfrm>
+            <a:off x="809625" y="1767921"/>
+            <a:ext cx="4400550" cy="4400550"/>
+          </a:xfrm>
+          <a:prstGeom prst="rect">
+            <a:avLst/>
+          </a:prstGeom>
+        </p:spPr>
+      </p:pic>
+    </p:spTree>
+    <p:extLst>
+      <p:ext uri="{BB962C8B-B14F-4D97-AF65-F5344CB8AC3E}">
+        <p14:creationId xmlns:p14="http://schemas.microsoft.com/office/powerpoint/2010/main" val="2014083808"/>
+      </p:ext>
+    </p:extLst>
+  </p:cSld>
+  <p:clrMapOvr>
+    <a:masterClrMapping/>
+  </p:clrMapOvr>
+</p:sld>
+</file>
+
+<file path=ppt/slides/slide16.xml><?xml version="1.0" encoding="utf-8"?>
+<p:sld xmlns:a="http://schemas.openxmlformats.org/drawingml/2006/main" xmlns:r="http://schemas.openxmlformats.org/officeDocument/2006/relationships" xmlns:p="http://schemas.openxmlformats.org/presentationml/2006/main">
+  <p:cSld>
+    <p:spTree>
+      <p:nvGrpSpPr>
+        <p:cNvPr id="1" name="">
+          <a:extLst>
+            <a:ext uri="{FF2B5EF4-FFF2-40B4-BE49-F238E27FC236}">
+              <a16:creationId xmlns:a16="http://schemas.microsoft.com/office/drawing/2014/main" id="{5997B4E1-154F-A649-2990-27AC8043E749}"/>
+            </a:ext>
+          </a:extLst>
+        </p:cNvPr>
+        <p:cNvGrpSpPr/>
+        <p:nvPr/>
+      </p:nvGrpSpPr>
+      <p:grpSpPr>
+        <a:xfrm>
+          <a:off x="0" y="0"/>
+          <a:ext cx="0" cy="0"/>
+          <a:chOff x="0" y="0"/>
+          <a:chExt cx="0" cy="0"/>
+        </a:xfrm>
+      </p:grpSpPr>
+      <p:sp>
+        <p:nvSpPr>
+          <p:cNvPr id="5" name="Title 4">
+            <a:extLst>
+              <a:ext uri="{FF2B5EF4-FFF2-40B4-BE49-F238E27FC236}">
+                <a16:creationId xmlns:a16="http://schemas.microsoft.com/office/drawing/2014/main" id="{3466028A-B6AE-4168-08E8-7C914C231536}"/>
+              </a:ext>
+            </a:extLst>
+          </p:cNvPr>
+          <p:cNvSpPr>
+            <a:spLocks noGrp="1"/>
+          </p:cNvSpPr>
+          <p:nvPr>
+            <p:ph type="title"/>
+          </p:nvPr>
+        </p:nvSpPr>
+        <p:spPr>
+          <a:xfrm>
+            <a:off x="733425" y="0"/>
+            <a:ext cx="10515600" cy="1325563"/>
+          </a:xfrm>
+        </p:spPr>
+        <p:txBody>
+          <a:bodyPr>
+            <a:normAutofit/>
+          </a:bodyPr>
+          <a:lstStyle/>
+          <a:p>
+            <a:r>
+              <a:rPr lang="en-US" sz="4000" dirty="0"/>
+              <a:t>Appendices (Descriptive Data): Wind Direction</a:t>
+            </a:r>
+          </a:p>
+        </p:txBody>
+      </p:sp>
+      <p:pic>
+        <p:nvPicPr>
+          <p:cNvPr id="13" name="Content Placeholder 12">
+            <a:extLst>
+              <a:ext uri="{FF2B5EF4-FFF2-40B4-BE49-F238E27FC236}">
+                <a16:creationId xmlns:a16="http://schemas.microsoft.com/office/drawing/2014/main" id="{4C15FACB-80DB-3369-38CB-508717602E70}"/>
+              </a:ext>
+            </a:extLst>
+          </p:cNvPr>
+          <p:cNvPicPr>
+            <a:picLocks noGrp="1" noChangeAspect="1"/>
+          </p:cNvPicPr>
+          <p:nvPr>
+            <p:ph sz="half" idx="2"/>
+          </p:nvPr>
+        </p:nvPicPr>
+        <p:blipFill>
+          <a:blip r:embed="rId2">
+            <a:extLst>
+              <a:ext uri="{28A0092B-C50C-407E-A947-70E740481C1C}">
+                <a14:useLocalDpi xmlns:a14="http://schemas.microsoft.com/office/drawing/2010/main" val="0"/>
+              </a:ext>
+            </a:extLst>
+          </a:blip>
+          <a:stretch>
+            <a:fillRect/>
+          </a:stretch>
+        </p:blipFill>
+        <p:spPr>
+          <a:xfrm>
+            <a:off x="478758" y="1760260"/>
+            <a:ext cx="4674274" cy="4674274"/>
+          </a:xfrm>
+          <a:prstGeom prst="rect">
+            <a:avLst/>
+          </a:prstGeom>
+        </p:spPr>
+      </p:pic>
+      <p:sp>
+        <p:nvSpPr>
+          <p:cNvPr id="16" name="TextBox 15">
+            <a:extLst>
+              <a:ext uri="{FF2B5EF4-FFF2-40B4-BE49-F238E27FC236}">
+                <a16:creationId xmlns:a16="http://schemas.microsoft.com/office/drawing/2014/main" id="{57744FFD-0BD5-B498-C937-661589C1A6F9}"/>
+              </a:ext>
+            </a:extLst>
+          </p:cNvPr>
+          <p:cNvSpPr txBox="1"/>
+          <p:nvPr/>
+        </p:nvSpPr>
+        <p:spPr>
+          <a:xfrm>
+            <a:off x="4495800" y="1390928"/>
+            <a:ext cx="2990850" cy="369332"/>
+          </a:xfrm>
+          <a:prstGeom prst="rect">
+            <a:avLst/>
+          </a:prstGeom>
+          <a:noFill/>
+        </p:spPr>
+        <p:txBody>
+          <a:bodyPr wrap="square" rtlCol="0">
+            <a:spAutoFit/>
+          </a:bodyPr>
+          <a:lstStyle/>
+          <a:p>
+            <a:pPr algn="ctr"/>
+            <a:r>
+              <a:rPr lang="en-US" b="1" dirty="0"/>
+              <a:t>May-August 2026</a:t>
+            </a:r>
+          </a:p>
+        </p:txBody>
+      </p:sp>
+      <p:pic>
+        <p:nvPicPr>
+          <p:cNvPr id="6" name="Picture 5">
+            <a:extLst>
+              <a:ext uri="{FF2B5EF4-FFF2-40B4-BE49-F238E27FC236}">
+                <a16:creationId xmlns:a16="http://schemas.microsoft.com/office/drawing/2014/main" id="{4CF2DFB9-07CD-5B8A-A5BD-27032714F58D}"/>
+              </a:ext>
+            </a:extLst>
+          </p:cNvPr>
+          <p:cNvPicPr>
+            <a:picLocks noChangeAspect="1"/>
+          </p:cNvPicPr>
+          <p:nvPr/>
+        </p:nvPicPr>
+        <p:blipFill>
+          <a:blip r:embed="rId3">
+            <a:extLst>
+              <a:ext uri="{28A0092B-C50C-407E-A947-70E740481C1C}">
+                <a14:useLocalDpi xmlns:a14="http://schemas.microsoft.com/office/drawing/2010/main" val="0"/>
+              </a:ext>
+            </a:extLst>
+          </a:blip>
+          <a:stretch>
+            <a:fillRect/>
+          </a:stretch>
+        </p:blipFill>
+        <p:spPr>
+          <a:xfrm>
+            <a:off x="7153267" y="1760261"/>
+            <a:ext cx="4183340" cy="4183340"/>
+          </a:xfrm>
+          <a:prstGeom prst="rect">
+            <a:avLst/>
+          </a:prstGeom>
+        </p:spPr>
+      </p:pic>
+    </p:spTree>
+    <p:extLst>
+      <p:ext uri="{BB962C8B-B14F-4D97-AF65-F5344CB8AC3E}">
+        <p14:creationId xmlns:p14="http://schemas.microsoft.com/office/powerpoint/2010/main" val="4226288996"/>
+      </p:ext>
+    </p:extLst>
+  </p:cSld>
+  <p:clrMapOvr>
+    <a:masterClrMapping/>
+  </p:clrMapOvr>
+</p:sld>
+</file>
+
+<file path=ppt/slides/slide17.xml><?xml version="1.0" encoding="utf-8"?>
+<p:sld xmlns:a="http://schemas.openxmlformats.org/drawingml/2006/main" xmlns:r="http://schemas.openxmlformats.org/officeDocument/2006/relationships" xmlns:p="http://schemas.openxmlformats.org/presentationml/2006/main">
+  <p:cSld>
+    <p:spTree>
+      <p:nvGrpSpPr>
+        <p:cNvPr id="1" name=""/>
+        <p:cNvGrpSpPr/>
+        <p:nvPr/>
+      </p:nvGrpSpPr>
+      <p:grpSpPr>
+        <a:xfrm>
+          <a:off x="0" y="0"/>
+          <a:ext cx="0" cy="0"/>
+          <a:chOff x="0" y="0"/>
+          <a:chExt cx="0" cy="0"/>
+        </a:xfrm>
+      </p:grpSpPr>
+      <p:pic>
+        <p:nvPicPr>
+          <p:cNvPr id="13" name="Content Placeholder 12">
+            <a:extLst>
+              <a:ext uri="{FF2B5EF4-FFF2-40B4-BE49-F238E27FC236}">
+                <a16:creationId xmlns:a16="http://schemas.microsoft.com/office/drawing/2014/main" id="{4C7567C2-EA05-EA38-EF7F-4F82C1F9E5D1}"/>
+              </a:ext>
+            </a:extLst>
+          </p:cNvPr>
+          <p:cNvPicPr>
+            <a:picLocks noGrp="1" noChangeAspect="1"/>
+          </p:cNvPicPr>
+          <p:nvPr>
+            <p:ph idx="1"/>
+          </p:nvPr>
+        </p:nvPicPr>
+        <p:blipFill>
+          <a:blip r:embed="rId2"/>
+          <a:stretch>
+            <a:fillRect/>
+          </a:stretch>
+        </p:blipFill>
+        <p:spPr>
+          <a:xfrm>
+            <a:off x="6576419" y="2162899"/>
+            <a:ext cx="5162720" cy="3254490"/>
+          </a:xfrm>
+          <a:prstGeom prst="rect">
+            <a:avLst/>
+          </a:prstGeom>
+        </p:spPr>
+      </p:pic>
+      <p:pic>
+        <p:nvPicPr>
+          <p:cNvPr id="17" name="Picture 16">
+            <a:extLst>
+              <a:ext uri="{FF2B5EF4-FFF2-40B4-BE49-F238E27FC236}">
+                <a16:creationId xmlns:a16="http://schemas.microsoft.com/office/drawing/2014/main" id="{726B37FA-9DE5-3D3E-5230-48ABA774FB4D}"/>
+              </a:ext>
+            </a:extLst>
+          </p:cNvPr>
+          <p:cNvPicPr>
+            <a:picLocks noChangeAspect="1"/>
+          </p:cNvPicPr>
+          <p:nvPr/>
+        </p:nvPicPr>
+        <p:blipFill>
+          <a:blip r:embed="rId3"/>
+          <a:stretch>
+            <a:fillRect/>
+          </a:stretch>
+        </p:blipFill>
+        <p:spPr>
+          <a:xfrm>
+            <a:off x="635071" y="2162899"/>
+            <a:ext cx="5460929" cy="3428650"/>
+          </a:xfrm>
+          <a:prstGeom prst="rect">
+            <a:avLst/>
+          </a:prstGeom>
+        </p:spPr>
+      </p:pic>
+      <p:sp>
+        <p:nvSpPr>
+          <p:cNvPr id="5" name="Title 4">
+            <a:extLst>
+              <a:ext uri="{FF2B5EF4-FFF2-40B4-BE49-F238E27FC236}">
+                <a16:creationId xmlns:a16="http://schemas.microsoft.com/office/drawing/2014/main" id="{882C92FD-D86D-90B4-81AA-98FAAE246598}"/>
+              </a:ext>
+            </a:extLst>
+          </p:cNvPr>
+          <p:cNvSpPr>
+            <a:spLocks noGrp="1"/>
+          </p:cNvSpPr>
+          <p:nvPr>
+            <p:ph type="title"/>
+          </p:nvPr>
+        </p:nvSpPr>
+        <p:spPr/>
+        <p:txBody>
+          <a:bodyPr/>
+          <a:lstStyle/>
+          <a:p>
+            <a:r>
+              <a:rPr lang="en-US" dirty="0"/>
+              <a:t>Appendices (Descriptive Data): Wind Speed</a:t>
+            </a:r>
+          </a:p>
+        </p:txBody>
+      </p:sp>
+    </p:spTree>
+    <p:extLst>
+      <p:ext uri="{BB962C8B-B14F-4D97-AF65-F5344CB8AC3E}">
+        <p14:creationId xmlns:p14="http://schemas.microsoft.com/office/powerpoint/2010/main" val="1405136645"/>
+      </p:ext>
+    </p:extLst>
+  </p:cSld>
+  <p:clrMapOvr>
+    <a:masterClrMapping/>
+  </p:clrMapOvr>
+</p:sld>
+</file>
+
+<file path=ppt/slides/slide18.xml><?xml version="1.0" encoding="utf-8"?>
+<p:sld xmlns:a="http://schemas.openxmlformats.org/drawingml/2006/main" xmlns:r="http://schemas.openxmlformats.org/officeDocument/2006/relationships" xmlns:p="http://schemas.openxmlformats.org/presentationml/2006/main">
+  <p:cSld>
+    <p:spTree>
+      <p:nvGrpSpPr>
+        <p:cNvPr id="1" name=""/>
+        <p:cNvGrpSpPr/>
+        <p:nvPr/>
+      </p:nvGrpSpPr>
+      <p:grpSpPr>
+        <a:xfrm>
+          <a:off x="0" y="0"/>
+          <a:ext cx="0" cy="0"/>
+          <a:chOff x="0" y="0"/>
+          <a:chExt cx="0" cy="0"/>
+        </a:xfrm>
+      </p:grpSpPr>
+      <p:sp>
+        <p:nvSpPr>
+          <p:cNvPr id="2" name="Title 1">
+            <a:extLst>
+              <a:ext uri="{FF2B5EF4-FFF2-40B4-BE49-F238E27FC236}">
+                <a16:creationId xmlns:a16="http://schemas.microsoft.com/office/drawing/2014/main" id="{09088601-E465-1B77-5DFB-E21827DA476A}"/>
+              </a:ext>
+            </a:extLst>
+          </p:cNvPr>
+          <p:cNvSpPr>
+            <a:spLocks noGrp="1"/>
+          </p:cNvSpPr>
+          <p:nvPr>
+            <p:ph type="title"/>
+          </p:nvPr>
+        </p:nvSpPr>
+        <p:spPr/>
+        <p:txBody>
+          <a:bodyPr>
+            <a:normAutofit/>
+          </a:bodyPr>
+          <a:lstStyle/>
+          <a:p>
+            <a:r>
+              <a:rPr lang="en-US" dirty="0"/>
+              <a:t>Appendices (Descriptive Data): Slope</a:t>
+            </a:r>
+          </a:p>
+        </p:txBody>
+      </p:sp>
+      <p:pic>
+        <p:nvPicPr>
+          <p:cNvPr id="7" name="Picture 6">
+            <a:extLst>
+              <a:ext uri="{FF2B5EF4-FFF2-40B4-BE49-F238E27FC236}">
+                <a16:creationId xmlns:a16="http://schemas.microsoft.com/office/drawing/2014/main" id="{20941BF4-9E9F-5C22-FA4A-AD297C6EAEB7}"/>
+              </a:ext>
+            </a:extLst>
+          </p:cNvPr>
+          <p:cNvPicPr>
+            <a:picLocks noChangeAspect="1"/>
+          </p:cNvPicPr>
+          <p:nvPr/>
+        </p:nvPicPr>
+        <p:blipFill>
+          <a:blip r:embed="rId2"/>
+          <a:stretch>
+            <a:fillRect/>
+          </a:stretch>
+        </p:blipFill>
+        <p:spPr>
+          <a:xfrm>
+            <a:off x="6305240" y="2406770"/>
+            <a:ext cx="4965746" cy="3001992"/>
+          </a:xfrm>
+          <a:prstGeom prst="rect">
+            <a:avLst/>
+          </a:prstGeom>
+        </p:spPr>
+      </p:pic>
+      <p:pic>
+        <p:nvPicPr>
+          <p:cNvPr id="11" name="Content Placeholder 10">
+            <a:extLst>
+              <a:ext uri="{FF2B5EF4-FFF2-40B4-BE49-F238E27FC236}">
+                <a16:creationId xmlns:a16="http://schemas.microsoft.com/office/drawing/2014/main" id="{DEFE12E2-1EED-6518-94C9-AB0F5F088D46}"/>
+              </a:ext>
+            </a:extLst>
+          </p:cNvPr>
+          <p:cNvPicPr>
+            <a:picLocks noGrp="1" noChangeAspect="1"/>
+          </p:cNvPicPr>
+          <p:nvPr>
+            <p:ph idx="1"/>
+          </p:nvPr>
+        </p:nvPicPr>
+        <p:blipFill>
+          <a:blip r:embed="rId3"/>
+          <a:stretch>
+            <a:fillRect/>
+          </a:stretch>
+        </p:blipFill>
+        <p:spPr>
+          <a:xfrm>
+            <a:off x="938408" y="2457746"/>
+            <a:ext cx="4832664" cy="3100527"/>
+          </a:xfrm>
+          <a:prstGeom prst="rect">
+            <a:avLst/>
+          </a:prstGeom>
+        </p:spPr>
+      </p:pic>
+      <p:sp>
+        <p:nvSpPr>
+          <p:cNvPr id="3" name="TextBox 2">
+            <a:extLst>
+              <a:ext uri="{FF2B5EF4-FFF2-40B4-BE49-F238E27FC236}">
+                <a16:creationId xmlns:a16="http://schemas.microsoft.com/office/drawing/2014/main" id="{E3C8B9F9-8670-9659-A378-8E86907B9F4D}"/>
+              </a:ext>
+            </a:extLst>
+          </p:cNvPr>
+          <p:cNvSpPr txBox="1"/>
+          <p:nvPr/>
+        </p:nvSpPr>
+        <p:spPr>
+          <a:xfrm>
+            <a:off x="1035170" y="1621766"/>
+            <a:ext cx="3019245" cy="369332"/>
+          </a:xfrm>
+          <a:prstGeom prst="rect">
+            <a:avLst/>
+          </a:prstGeom>
+          <a:noFill/>
+        </p:spPr>
+        <p:txBody>
+          <a:bodyPr wrap="square" rtlCol="0">
+            <a:spAutoFit/>
+          </a:bodyPr>
+          <a:lstStyle/>
+          <a:p>
+            <a:r>
+              <a:rPr lang="en-US" dirty="0"/>
+              <a:t>Local Slope</a:t>
+            </a:r>
+          </a:p>
+        </p:txBody>
+      </p:sp>
+    </p:spTree>
+    <p:extLst>
+      <p:ext uri="{BB962C8B-B14F-4D97-AF65-F5344CB8AC3E}">
+        <p14:creationId xmlns:p14="http://schemas.microsoft.com/office/powerpoint/2010/main" val="3100768396"/>
+      </p:ext>
+    </p:extLst>
+  </p:cSld>
+  <p:clrMapOvr>
+    <a:masterClrMapping/>
+  </p:clrMapOvr>
+</p:sld>
+</file>
+
+<file path=ppt/slides/slide19.xml><?xml version="1.0" encoding="utf-8"?>
+<p:sld xmlns:a="http://schemas.openxmlformats.org/drawingml/2006/main" xmlns:r="http://schemas.openxmlformats.org/officeDocument/2006/relationships" xmlns:p="http://schemas.openxmlformats.org/presentationml/2006/main">
+  <p:cSld>
+    <p:spTree>
+      <p:nvGrpSpPr>
+        <p:cNvPr id="1" name="">
+          <a:extLst>
+            <a:ext uri="{FF2B5EF4-FFF2-40B4-BE49-F238E27FC236}">
+              <a16:creationId xmlns:a16="http://schemas.microsoft.com/office/drawing/2014/main" id="{03FDB5F5-8191-57F8-0EB5-A3BECADF3DB2}"/>
+            </a:ext>
+          </a:extLst>
+        </p:cNvPr>
+        <p:cNvGrpSpPr/>
+        <p:nvPr/>
+      </p:nvGrpSpPr>
+      <p:grpSpPr>
+        <a:xfrm>
+          <a:off x="0" y="0"/>
+          <a:ext cx="0" cy="0"/>
+          <a:chOff x="0" y="0"/>
+          <a:chExt cx="0" cy="0"/>
+        </a:xfrm>
+      </p:grpSpPr>
+      <p:sp>
+        <p:nvSpPr>
+          <p:cNvPr id="2" name="Title 1">
+            <a:extLst>
+              <a:ext uri="{FF2B5EF4-FFF2-40B4-BE49-F238E27FC236}">
+                <a16:creationId xmlns:a16="http://schemas.microsoft.com/office/drawing/2014/main" id="{835E6846-7F90-41CF-AB87-E4E17A756E9C}"/>
+              </a:ext>
+            </a:extLst>
+          </p:cNvPr>
+          <p:cNvSpPr>
+            <a:spLocks noGrp="1"/>
+          </p:cNvSpPr>
+          <p:nvPr>
+            <p:ph type="title"/>
+          </p:nvPr>
+        </p:nvSpPr>
+        <p:spPr/>
+        <p:txBody>
+          <a:bodyPr>
+            <a:normAutofit/>
+          </a:bodyPr>
+          <a:lstStyle/>
+          <a:p>
+            <a:r>
+              <a:rPr lang="en-US" sz="4000" dirty="0"/>
+              <a:t>Appendices (Descriptive Data): Elevation Profile</a:t>
+            </a:r>
+          </a:p>
+        </p:txBody>
+      </p:sp>
+      <p:pic>
+        <p:nvPicPr>
+          <p:cNvPr id="8" name="Picture 7">
+            <a:extLst>
+              <a:ext uri="{FF2B5EF4-FFF2-40B4-BE49-F238E27FC236}">
+                <a16:creationId xmlns:a16="http://schemas.microsoft.com/office/drawing/2014/main" id="{F9B62FE9-BE28-E814-3362-D04504F36D6C}"/>
+              </a:ext>
+            </a:extLst>
+          </p:cNvPr>
+          <p:cNvPicPr>
+            <a:picLocks noChangeAspect="1"/>
+          </p:cNvPicPr>
+          <p:nvPr/>
+        </p:nvPicPr>
+        <p:blipFill>
+          <a:blip r:embed="rId2">
+            <a:extLst>
+              <a:ext uri="{28A0092B-C50C-407E-A947-70E740481C1C}">
+                <a14:useLocalDpi xmlns:a14="http://schemas.microsoft.com/office/drawing/2010/main" val="0"/>
+              </a:ext>
+            </a:extLst>
+          </a:blip>
+          <a:srcRect t="3828"/>
+          <a:stretch>
+            <a:fillRect/>
+          </a:stretch>
+        </p:blipFill>
+        <p:spPr>
+          <a:xfrm>
+            <a:off x="0" y="2658913"/>
+            <a:ext cx="5916231" cy="3186262"/>
+          </a:xfrm>
+          <a:prstGeom prst="rect">
+            <a:avLst/>
+          </a:prstGeom>
+        </p:spPr>
+      </p:pic>
+      <p:pic>
+        <p:nvPicPr>
+          <p:cNvPr id="10" name="Picture 9">
+            <a:extLst>
+              <a:ext uri="{FF2B5EF4-FFF2-40B4-BE49-F238E27FC236}">
+                <a16:creationId xmlns:a16="http://schemas.microsoft.com/office/drawing/2014/main" id="{89BEF38C-8DD8-0242-73CB-3542E5DA72E7}"/>
+              </a:ext>
+            </a:extLst>
+          </p:cNvPr>
+          <p:cNvPicPr>
+            <a:picLocks noChangeAspect="1"/>
+          </p:cNvPicPr>
+          <p:nvPr/>
+        </p:nvPicPr>
+        <p:blipFill>
+          <a:blip r:embed="rId3">
+            <a:extLst>
+              <a:ext uri="{28A0092B-C50C-407E-A947-70E740481C1C}">
+                <a14:useLocalDpi xmlns:a14="http://schemas.microsoft.com/office/drawing/2010/main" val="0"/>
+              </a:ext>
+            </a:extLst>
+          </a:blip>
+          <a:srcRect t="5114" r="770"/>
+          <a:stretch>
+            <a:fillRect/>
+          </a:stretch>
+        </p:blipFill>
+        <p:spPr>
+          <a:xfrm>
+            <a:off x="6096000" y="2570647"/>
+            <a:ext cx="5950250" cy="3186262"/>
+          </a:xfrm>
+          <a:prstGeom prst="rect">
+            <a:avLst/>
+          </a:prstGeom>
+        </p:spPr>
+      </p:pic>
+      <p:sp>
+        <p:nvSpPr>
+          <p:cNvPr id="12" name="TextBox 11">
+            <a:extLst>
+              <a:ext uri="{FF2B5EF4-FFF2-40B4-BE49-F238E27FC236}">
+                <a16:creationId xmlns:a16="http://schemas.microsoft.com/office/drawing/2014/main" id="{559984F5-70D9-812F-90FE-1F2FAF1A0BFF}"/>
+              </a:ext>
+            </a:extLst>
+          </p:cNvPr>
+          <p:cNvSpPr txBox="1"/>
+          <p:nvPr/>
+        </p:nvSpPr>
+        <p:spPr>
+          <a:xfrm>
+            <a:off x="1869211" y="2012582"/>
+            <a:ext cx="3212980" cy="523220"/>
+          </a:xfrm>
+          <a:prstGeom prst="rect">
+            <a:avLst/>
+          </a:prstGeom>
+          <a:noFill/>
+        </p:spPr>
+        <p:txBody>
+          <a:bodyPr wrap="square" rtlCol="0">
+            <a:spAutoFit/>
+          </a:bodyPr>
+          <a:lstStyle/>
+          <a:p>
+            <a:pPr algn="ctr"/>
+            <a:r>
+              <a:rPr lang="en-US" sz="1400" b="1" dirty="0"/>
+              <a:t>Ramped Sites </a:t>
+            </a:r>
+          </a:p>
+          <a:p>
+            <a:pPr algn="ctr"/>
+            <a:r>
+              <a:rPr lang="en-US" sz="1400" b="1" dirty="0"/>
+              <a:t>(San Pablo and Buck’s Landing)</a:t>
+            </a:r>
+          </a:p>
+        </p:txBody>
+      </p:sp>
+      <p:sp>
+        <p:nvSpPr>
+          <p:cNvPr id="16" name="TextBox 15">
+            <a:extLst>
+              <a:ext uri="{FF2B5EF4-FFF2-40B4-BE49-F238E27FC236}">
+                <a16:creationId xmlns:a16="http://schemas.microsoft.com/office/drawing/2014/main" id="{B906DF8C-8A46-E58E-A72D-FAE9A6358388}"/>
+              </a:ext>
+            </a:extLst>
+          </p:cNvPr>
+          <p:cNvSpPr txBox="1"/>
+          <p:nvPr/>
+        </p:nvSpPr>
+        <p:spPr>
+          <a:xfrm>
+            <a:off x="7922079" y="1913190"/>
+            <a:ext cx="3212980" cy="523220"/>
+          </a:xfrm>
+          <a:prstGeom prst="rect">
+            <a:avLst/>
+          </a:prstGeom>
+          <a:noFill/>
+        </p:spPr>
+        <p:txBody>
+          <a:bodyPr wrap="square" rtlCol="0">
+            <a:spAutoFit/>
+          </a:bodyPr>
+          <a:lstStyle/>
+          <a:p>
+            <a:pPr algn="ctr"/>
+            <a:r>
+              <a:rPr lang="en-US" sz="1400" b="1" dirty="0"/>
+              <a:t>Scarped Sites</a:t>
+            </a:r>
+          </a:p>
+          <a:p>
+            <a:pPr algn="ctr"/>
+            <a:r>
+              <a:rPr lang="en-US" sz="1400" b="1" dirty="0"/>
+              <a:t>(Corte Madera and Buck’s Landing)</a:t>
+            </a:r>
+          </a:p>
+        </p:txBody>
+      </p:sp>
+    </p:spTree>
+    <p:extLst>
+      <p:ext uri="{BB962C8B-B14F-4D97-AF65-F5344CB8AC3E}">
+        <p14:creationId xmlns:p14="http://schemas.microsoft.com/office/powerpoint/2010/main" val="1111395093"/>
+      </p:ext>
+    </p:extLst>
+  </p:cSld>
+  <p:clrMapOvr>
+    <a:masterClrMapping/>
+  </p:clrMapOvr>
+</p:sld>
+</file>
+
+<file path=ppt/slides/slide2.xml><?xml version="1.0" encoding="utf-8"?>
+<p:sld xmlns:a="http://schemas.openxmlformats.org/drawingml/2006/main" xmlns:r="http://schemas.openxmlformats.org/officeDocument/2006/relationships" xmlns:p="http://schemas.openxmlformats.org/presentationml/2006/main">
+  <p:cSld>
+    <p:spTree>
+      <p:nvGrpSpPr>
+        <p:cNvPr id="1" name=""/>
+        <p:cNvGrpSpPr/>
+        <p:nvPr/>
+      </p:nvGrpSpPr>
+      <p:grpSpPr>
+        <a:xfrm>
+          <a:off x="0" y="0"/>
+          <a:ext cx="0" cy="0"/>
+          <a:chOff x="0" y="0"/>
+          <a:chExt cx="0" cy="0"/>
+        </a:xfrm>
+      </p:grpSpPr>
+      <p:sp>
+        <p:nvSpPr>
+          <p:cNvPr id="2" name="Title 1">
+            <a:extLst>
+              <a:ext uri="{FF2B5EF4-FFF2-40B4-BE49-F238E27FC236}">
+                <a16:creationId xmlns:a16="http://schemas.microsoft.com/office/drawing/2014/main" id="{88A78E77-2410-48D8-E204-60A734D8DC23}"/>
+              </a:ext>
+            </a:extLst>
+          </p:cNvPr>
+          <p:cNvSpPr>
+            <a:spLocks noGrp="1"/>
+          </p:cNvSpPr>
+          <p:nvPr>
+            <p:ph type="title"/>
+          </p:nvPr>
+        </p:nvSpPr>
+        <p:spPr/>
+        <p:txBody>
+          <a:bodyPr/>
+          <a:lstStyle/>
+          <a:p>
+            <a:r>
+              <a:rPr lang="en-US" dirty="0"/>
+              <a:t>Summary-Sediment and Abiotic Variables</a:t>
+            </a:r>
+          </a:p>
+        </p:txBody>
+      </p:sp>
+      <p:sp>
+        <p:nvSpPr>
+          <p:cNvPr id="3" name="Content Placeholder 2">
+            <a:extLst>
+              <a:ext uri="{FF2B5EF4-FFF2-40B4-BE49-F238E27FC236}">
+                <a16:creationId xmlns:a16="http://schemas.microsoft.com/office/drawing/2014/main" id="{22F931F0-4409-18B6-3C54-02E0CF904623}"/>
+              </a:ext>
+            </a:extLst>
+          </p:cNvPr>
+          <p:cNvSpPr>
+            <a:spLocks noGrp="1"/>
+          </p:cNvSpPr>
+          <p:nvPr>
+            <p:ph idx="1"/>
+          </p:nvPr>
+        </p:nvSpPr>
+        <p:spPr/>
+        <p:txBody>
+          <a:bodyPr>
+            <a:normAutofit fontScale="92500" lnSpcReduction="10000"/>
+          </a:bodyPr>
+          <a:lstStyle/>
+          <a:p>
+            <a:pPr marL="0" indent="0">
+              <a:buNone/>
+            </a:pPr>
+            <a:r>
+              <a:rPr lang="en-US" b="1" dirty="0"/>
+              <a:t>Merged USGS and Thesis Sediment Deposition data into one </a:t>
+            </a:r>
+            <a:r>
+              <a:rPr lang="en-US" b="1" dirty="0" err="1"/>
+              <a:t>dataframe</a:t>
+            </a:r>
+            <a:r>
+              <a:rPr lang="en-US" b="1" dirty="0"/>
+              <a:t>! </a:t>
+            </a:r>
+          </a:p>
+          <a:p>
+            <a:pPr marL="0" indent="0">
+              <a:buNone/>
+            </a:pPr>
+            <a:r>
+              <a:rPr lang="en-US" dirty="0"/>
+              <a:t>Thesis includes additional variables:</a:t>
+            </a:r>
+          </a:p>
+          <a:p>
+            <a:pPr lvl="1"/>
+            <a:r>
+              <a:rPr lang="en-US" dirty="0"/>
+              <a:t>“local slope”</a:t>
+            </a:r>
+          </a:p>
+          <a:p>
+            <a:pPr lvl="2"/>
+            <a:r>
+              <a:rPr lang="en-US" dirty="0"/>
+              <a:t>Extrapolated from marsh edge horizontal profile (June 2025) to the most recent RTK surveys of the transect (Nov. 2025-March 2025)</a:t>
+            </a:r>
+          </a:p>
+          <a:p>
+            <a:pPr lvl="1"/>
+            <a:r>
+              <a:rPr lang="en-US" dirty="0"/>
+              <a:t>mean wind speed</a:t>
+            </a:r>
+          </a:p>
+          <a:p>
+            <a:pPr lvl="2"/>
+            <a:r>
+              <a:rPr lang="en-US" dirty="0"/>
+              <a:t>Calculated per site, spanning time of Day filter was placed-Day filter was collected</a:t>
+            </a:r>
+          </a:p>
+          <a:p>
+            <a:pPr marL="0" indent="0">
+              <a:buNone/>
+            </a:pPr>
+            <a:r>
+              <a:rPr lang="en-US" dirty="0"/>
+              <a:t>USGS includes additional variables and elements: </a:t>
+            </a:r>
+          </a:p>
+          <a:p>
+            <a:pPr lvl="1"/>
+            <a:r>
+              <a:rPr lang="en-US" dirty="0"/>
+              <a:t>Bay (Transects A, B) and Channel (Transects C, D) incorporated in data frames</a:t>
+            </a:r>
+          </a:p>
+          <a:p>
+            <a:pPr lvl="1"/>
+            <a:r>
+              <a:rPr lang="en-US" dirty="0"/>
+              <a:t>Calculated z* to pair with thesis measurements </a:t>
+            </a:r>
+          </a:p>
+          <a:p>
+            <a:pPr lvl="2"/>
+            <a:r>
+              <a:rPr lang="en-US" dirty="0"/>
+              <a:t>Used same BCDC stations as Thesis for standardization </a:t>
+            </a:r>
+          </a:p>
+          <a:p>
+            <a:pPr marL="914400" lvl="2" indent="0">
+              <a:buNone/>
+            </a:pPr>
+            <a:endParaRPr lang="en-US" dirty="0"/>
+          </a:p>
+          <a:p>
+            <a:endParaRPr lang="en-US" dirty="0"/>
+          </a:p>
+        </p:txBody>
+      </p:sp>
+    </p:spTree>
+    <p:extLst>
+      <p:ext uri="{BB962C8B-B14F-4D97-AF65-F5344CB8AC3E}">
+        <p14:creationId xmlns:p14="http://schemas.microsoft.com/office/powerpoint/2010/main" val="1137524809"/>
+      </p:ext>
+    </p:extLst>
+  </p:cSld>
+  <p:clrMapOvr>
+    <a:masterClrMapping/>
+  </p:clrMapOvr>
+</p:sld>
+</file>
+
+<file path=ppt/slides/slide3.xml><?xml version="1.0" encoding="utf-8"?>
 <p:sld xmlns:a="http://schemas.openxmlformats.org/drawingml/2006/main" xmlns:r="http://schemas.openxmlformats.org/officeDocument/2006/relationships" xmlns:p="http://schemas.openxmlformats.org/presentationml/2006/main">
   <p:cSld>
     <p:spTree>
@@ -5176,7 +6319,7 @@
 </p:sld>
 </file>
 
-<file path=ppt/slides/slide5.xml><?xml version="1.0" encoding="utf-8"?>
+<file path=ppt/slides/slide4.xml><?xml version="1.0" encoding="utf-8"?>
 <p:sld xmlns:a="http://schemas.openxmlformats.org/drawingml/2006/main" xmlns:r="http://schemas.openxmlformats.org/officeDocument/2006/relationships" xmlns:p="http://schemas.openxmlformats.org/presentationml/2006/main">
   <p:cSld>
     <p:spTree>
@@ -5392,7 +6535,7 @@
 </p:sld>
 </file>
 
-<file path=ppt/slides/slide6.xml><?xml version="1.0" encoding="utf-8"?>
+<file path=ppt/slides/slide5.xml><?xml version="1.0" encoding="utf-8"?>
 <p:sld xmlns:a="http://schemas.openxmlformats.org/drawingml/2006/main" xmlns:r="http://schemas.openxmlformats.org/officeDocument/2006/relationships" xmlns:p="http://schemas.openxmlformats.org/presentationml/2006/main">
   <p:cSld>
     <p:spTree>
@@ -5606,7 +6749,7 @@
 </p:sld>
 </file>
 
-<file path=ppt/slides/slide7.xml><?xml version="1.0" encoding="utf-8"?>
+<file path=ppt/slides/slide6.xml><?xml version="1.0" encoding="utf-8"?>
 <p:sld xmlns:a="http://schemas.openxmlformats.org/drawingml/2006/main" xmlns:r="http://schemas.openxmlformats.org/officeDocument/2006/relationships" xmlns:p="http://schemas.openxmlformats.org/presentationml/2006/main">
   <p:cSld>
     <p:spTree>
@@ -5675,7 +6818,7 @@
         </p:nvSpPr>
         <p:spPr>
           <a:xfrm>
-            <a:off x="1084709" y="1881323"/>
+            <a:off x="935227" y="1845968"/>
             <a:ext cx="3715891" cy="461666"/>
           </a:xfrm>
         </p:spPr>
@@ -5714,7 +6857,7 @@
         </p:blipFill>
         <p:spPr>
           <a:xfrm>
-            <a:off x="935227" y="3095497"/>
+            <a:off x="839788" y="3112857"/>
             <a:ext cx="7133780" cy="1272107"/>
           </a:xfrm>
           <a:prstGeom prst="rect">
@@ -5768,7 +6911,7 @@
         </p:nvSpPr>
         <p:spPr>
           <a:xfrm>
-            <a:off x="1084709" y="2422153"/>
+            <a:off x="935227" y="2422153"/>
             <a:ext cx="4161980" cy="461665"/>
           </a:xfrm>
           <a:prstGeom prst="rect">
@@ -5839,7 +6982,7 @@
 </p:sld>
 </file>
 
-<file path=ppt/slides/slide8.xml><?xml version="1.0" encoding="utf-8"?>
+<file path=ppt/slides/slide7.xml><?xml version="1.0" encoding="utf-8"?>
 <p:sld xmlns:a="http://schemas.openxmlformats.org/drawingml/2006/main" xmlns:r="http://schemas.openxmlformats.org/officeDocument/2006/relationships" xmlns:p="http://schemas.openxmlformats.org/presentationml/2006/main">
   <p:cSld>
     <p:spTree>
@@ -6040,7 +7183,7 @@
 </p:sld>
 </file>
 
-<file path=ppt/slides/slide9.xml><?xml version="1.0" encoding="utf-8"?>
+<file path=ppt/slides/slide8.xml><?xml version="1.0" encoding="utf-8"?>
 <p:sld xmlns:a="http://schemas.openxmlformats.org/drawingml/2006/main" xmlns:r="http://schemas.openxmlformats.org/officeDocument/2006/relationships" xmlns:p="http://schemas.openxmlformats.org/presentationml/2006/main">
   <p:cSld>
     <p:spTree>
@@ -6238,6 +7381,98 @@
     <p:extLst>
       <p:ext uri="{BB962C8B-B14F-4D97-AF65-F5344CB8AC3E}">
         <p14:creationId xmlns:p14="http://schemas.microsoft.com/office/powerpoint/2010/main" val="1399441668"/>
+      </p:ext>
+    </p:extLst>
+  </p:cSld>
+  <p:clrMapOvr>
+    <a:masterClrMapping/>
+  </p:clrMapOvr>
+</p:sld>
+</file>
+
+<file path=ppt/slides/slide9.xml><?xml version="1.0" encoding="utf-8"?>
+<p:sld xmlns:a="http://schemas.openxmlformats.org/drawingml/2006/main" xmlns:r="http://schemas.openxmlformats.org/officeDocument/2006/relationships" xmlns:p="http://schemas.openxmlformats.org/presentationml/2006/main">
+  <p:cSld>
+    <p:spTree>
+      <p:nvGrpSpPr>
+        <p:cNvPr id="1" name=""/>
+        <p:cNvGrpSpPr/>
+        <p:nvPr/>
+      </p:nvGrpSpPr>
+      <p:grpSpPr>
+        <a:xfrm>
+          <a:off x="0" y="0"/>
+          <a:ext cx="0" cy="0"/>
+          <a:chOff x="0" y="0"/>
+          <a:chExt cx="0" cy="0"/>
+        </a:xfrm>
+      </p:grpSpPr>
+      <p:sp>
+        <p:nvSpPr>
+          <p:cNvPr id="2" name="Title 1">
+            <a:extLst>
+              <a:ext uri="{FF2B5EF4-FFF2-40B4-BE49-F238E27FC236}">
+                <a16:creationId xmlns:a16="http://schemas.microsoft.com/office/drawing/2014/main" id="{828303BE-97E1-3299-8F4D-CD015365AE6C}"/>
+              </a:ext>
+            </a:extLst>
+          </p:cNvPr>
+          <p:cNvSpPr>
+            <a:spLocks noGrp="1"/>
+          </p:cNvSpPr>
+          <p:nvPr>
+            <p:ph type="title"/>
+          </p:nvPr>
+        </p:nvSpPr>
+        <p:spPr/>
+        <p:txBody>
+          <a:bodyPr>
+            <a:normAutofit/>
+          </a:bodyPr>
+          <a:lstStyle/>
+          <a:p>
+            <a:r>
+              <a:rPr lang="en-US" sz="4000" dirty="0"/>
+              <a:t>RQ #2: 2022/2023 Bay and Channel Transects</a:t>
+            </a:r>
+          </a:p>
+        </p:txBody>
+      </p:sp>
+      <p:pic>
+        <p:nvPicPr>
+          <p:cNvPr id="5" name="Content Placeholder 4">
+            <a:extLst>
+              <a:ext uri="{FF2B5EF4-FFF2-40B4-BE49-F238E27FC236}">
+                <a16:creationId xmlns:a16="http://schemas.microsoft.com/office/drawing/2014/main" id="{4B28ED72-DD4F-8C1D-A526-86EE4E1B9A61}"/>
+              </a:ext>
+            </a:extLst>
+          </p:cNvPr>
+          <p:cNvPicPr>
+            <a:picLocks noGrp="1" noChangeAspect="1"/>
+          </p:cNvPicPr>
+          <p:nvPr>
+            <p:ph idx="1"/>
+          </p:nvPr>
+        </p:nvPicPr>
+        <p:blipFill>
+          <a:blip r:embed="rId2"/>
+          <a:stretch>
+            <a:fillRect/>
+          </a:stretch>
+        </p:blipFill>
+        <p:spPr>
+          <a:xfrm>
+            <a:off x="2129392" y="1690688"/>
+            <a:ext cx="8311564" cy="4652762"/>
+          </a:xfrm>
+          <a:prstGeom prst="rect">
+            <a:avLst/>
+          </a:prstGeom>
+        </p:spPr>
+      </p:pic>
+    </p:spTree>
+    <p:extLst>
+      <p:ext uri="{BB962C8B-B14F-4D97-AF65-F5344CB8AC3E}">
+        <p14:creationId xmlns:p14="http://schemas.microsoft.com/office/powerpoint/2010/main" val="1610318545"/>
       </p:ext>
     </p:extLst>
   </p:cSld>

</xml_diff>